<commit_message>
Reframe Security slide around installer market vs smart cities
The Security business unit now tells one story: leadership in the
installer-driven market, rivals spending 19-51x more on R&D, smart
cities as the fastest-growing driver, and public projects won by
Hikvision, Dahua and Huawei, with Dahua free to compete in projects.
Core drivers (perception, construction, retrofit) move to the notes.

Co-Authored-By: Claude Opus 5.5 <noreply@anthropic.com>
Claude-Session: https://claude.ai/code/session_01KnzCLDRo32uUYqhzKjGgJD
</commit_message>
<xml_diff>
--- a/analise_setorial_intelbras_INTB3.pptx
+++ b/analise_setorial_intelbras_INTB3.pptx
@@ -571,482 +571,6 @@
   <c:chart>
     <c:autoTitleDeleted val="1"/>
     <c:plotArea>
-      <c:barChart>
-        <c:barDir val="col"/>
-        <c:grouping val="clustered"/>
-        <c:ser>
-          <c:idx val="0"/>
-          <c:order val="0"/>
-          <c:tx>
-            <c:strRef>
-              <c:f>Sheet1!$B$1</c:f>
-              <c:strCache>
-                <c:ptCount val="1"/>
-                <c:pt idx="0">
-                  <c:v>GW</c:v>
-                </c:pt>
-              </c:strCache>
-            </c:strRef>
-          </c:tx>
-          <c:spPr>
-            <a:solidFill>
-              <a:srgbClr val="595959"/>
-            </a:solidFill>
-          </c:spPr>
-          <c:invertIfNegative val="0"/>
-          <c:dLbls>
-            <c:dLbl>
-              <c:idx val="0"/>
-              <c:tx>
-                <c:rich>
-                  <a:bodyPr/>
-                  <a:lstStyle/>
-                  <a:p>
-                    <a:r>
-                      <a:rPr sz="950" b="1">
-                        <a:solidFill>
-                          <a:srgbClr val="595959"/>
-                        </a:solidFill>
-                      </a:rPr>
-                      <a:t>15,0</a:t>
-                    </a:r>
-                  </a:p>
-                </c:rich>
-              </c:tx>
-              <c:dLblPos val="outEnd"/>
-              <c:showLegendKey val="0"/>
-              <c:showVal val="1"/>
-              <c:showCatName val="0"/>
-              <c:showSerName val="0"/>
-              <c:showPercent val="0"/>
-              <c:showBubbleSize val="0"/>
-            </c:dLbl>
-            <c:dLbl>
-              <c:idx val="1"/>
-              <c:tx>
-                <c:rich>
-                  <a:bodyPr/>
-                  <a:lstStyle/>
-                  <a:p>
-                    <a:r>
-                      <a:rPr sz="950" b="1">
-                        <a:solidFill>
-                          <a:srgbClr val="595959"/>
-                        </a:solidFill>
-                      </a:rPr>
-                      <a:t>10,6</a:t>
-                    </a:r>
-                  </a:p>
-                </c:rich>
-              </c:tx>
-              <c:dLblPos val="outEnd"/>
-              <c:showLegendKey val="0"/>
-              <c:showVal val="1"/>
-              <c:showCatName val="0"/>
-              <c:showSerName val="0"/>
-              <c:showPercent val="0"/>
-              <c:showBubbleSize val="0"/>
-            </c:dLbl>
-            <c:showLegendKey val="0"/>
-            <c:showVal val="0"/>
-            <c:showCatName val="0"/>
-            <c:showSerName val="0"/>
-            <c:showPercent val="0"/>
-            <c:showBubbleSize val="0"/>
-            <c:showLeaderLines val="1"/>
-          </c:dLbls>
-          <c:cat>
-            <c:strRef>
-              <c:f>Sheet1!$A$2:$A$3</c:f>
-              <c:strCache>
-                <c:ptCount val="2"/>
-                <c:pt idx="0">
-                  <c:v>2024</c:v>
-                </c:pt>
-                <c:pt idx="1">
-                  <c:v>2025</c:v>
-                </c:pt>
-              </c:strCache>
-            </c:strRef>
-          </c:cat>
-          <c:val>
-            <c:numRef>
-              <c:f>Sheet1!$B$2:$B$3</c:f>
-              <c:numCache>
-                <c:formatCode>General</c:formatCode>
-                <c:ptCount val="2"/>
-                <c:pt idx="0">
-                  <c:v>15.0</c:v>
-                </c:pt>
-                <c:pt idx="1">
-                  <c:v>10.6</c:v>
-                </c:pt>
-              </c:numCache>
-            </c:numRef>
-          </c:val>
-        </c:ser>
-        <c:gapWidth val="50"/>
-        <c:overlap val="-5"/>
-        <c:axId val="-2068027336"/>
-        <c:axId val="-2113994440"/>
-      </c:barChart>
-      <c:catAx>
-        <c:axId val="-2068027336"/>
-        <c:scaling>
-          <c:orientation val="minMax"/>
-        </c:scaling>
-        <c:delete val="0"/>
-        <c:axPos val="b"/>
-        <c:majorTickMark val="none"/>
-        <c:minorTickMark val="none"/>
-        <c:tickLblPos val="nextTo"/>
-        <c:spPr>
-          <a:ln w="9525">
-            <a:solidFill>
-              <a:srgbClr val="BFBFBF"/>
-            </a:solidFill>
-          </a:ln>
-        </c:spPr>
-        <c:txPr>
-          <a:bodyPr/>
-          <a:lstStyle/>
-          <a:p>
-            <a:pPr>
-              <a:defRPr sz="900">
-                <a:solidFill>
-                  <a:srgbClr val="595959"/>
-                </a:solidFill>
-              </a:defRPr>
-            </a:pPr>
-          </a:p>
-        </c:txPr>
-        <c:crossAx val="-2113994440"/>
-        <c:crosses val="autoZero"/>
-        <c:auto val="1"/>
-        <c:lblAlgn val="ctr"/>
-        <c:lblOffset val="100"/>
-        <c:noMultiLvlLbl val="0"/>
-      </c:catAx>
-      <c:valAx>
-        <c:axId val="-2113994440"/>
-        <c:scaling>
-          <c:max val="18.0"/>
-          <c:min val="0.0"/>
-        </c:scaling>
-        <c:delete/>
-        <c:axPos val="l"/>
-        <c:majorTickMark val="out"/>
-        <c:minorTickMark val="none"/>
-        <c:tickLblPos val="nextTo"/>
-        <c:crossAx val="-2068027336"/>
-        <c:crosses val="autoZero"/>
-      </c:valAx>
-    </c:plotArea>
-    <c:dispBlanksAs val="gap"/>
-  </c:chart>
-  <c:spPr>
-    <a:noFill/>
-    <a:ln>
-      <a:noFill/>
-    </a:ln>
-  </c:spPr>
-  <c:txPr>
-    <a:bodyPr/>
-    <a:lstStyle/>
-    <a:p>
-      <a:pPr>
-        <a:defRPr sz="900">
-          <a:solidFill>
-            <a:srgbClr val="595959"/>
-          </a:solidFill>
-          <a:latin typeface="Calibri"/>
-        </a:defRPr>
-      </a:pPr>
-      <a:endParaRPr lang="en-US"/>
-    </a:p>
-  </c:txPr>
-  <c:externalData r:id="rId1">
-    <c:autoUpdate val="0"/>
-  </c:externalData>
-</c:chartSpace>
-</file>
-
-<file path=ppt/charts/chart11.xml><?xml version="1.0" encoding="utf-8"?>
-<c:chartSpace xmlns:c="http://schemas.openxmlformats.org/drawingml/2006/chart" xmlns:a="http://schemas.openxmlformats.org/drawingml/2006/main" xmlns:r="http://schemas.openxmlformats.org/officeDocument/2006/relationships">
-  <c:date1904 val="0"/>
-  <c:chart>
-    <c:autoTitleDeleted val="1"/>
-    <c:plotArea>
-      <c:barChart>
-        <c:barDir val="col"/>
-        <c:grouping val="clustered"/>
-        <c:ser>
-          <c:idx val="0"/>
-          <c:order val="0"/>
-          <c:tx>
-            <c:strRef>
-              <c:f>Sheet1!$B$1</c:f>
-              <c:strCache>
-                <c:ptCount val="1"/>
-                <c:pt idx="0">
-                  <c:v>Fio B</c:v>
-                </c:pt>
-              </c:strCache>
-            </c:strRef>
-          </c:tx>
-          <c:spPr>
-            <a:solidFill>
-              <a:srgbClr val="1A1A1A"/>
-            </a:solidFill>
-          </c:spPr>
-          <c:invertIfNegative val="0"/>
-          <c:dLbls>
-            <c:dLbl>
-              <c:idx val="0"/>
-              <c:tx>
-                <c:rich>
-                  <a:bodyPr/>
-                  <a:lstStyle/>
-                  <a:p>
-                    <a:r>
-                      <a:rPr sz="950" b="1">
-                        <a:solidFill>
-                          <a:srgbClr val="1A1A1A"/>
-                        </a:solidFill>
-                      </a:rPr>
-                      <a:t>45%</a:t>
-                    </a:r>
-                  </a:p>
-                </c:rich>
-              </c:tx>
-              <c:dLblPos val="outEnd"/>
-              <c:showLegendKey val="0"/>
-              <c:showVal val="1"/>
-              <c:showCatName val="0"/>
-              <c:showSerName val="0"/>
-              <c:showPercent val="0"/>
-              <c:showBubbleSize val="0"/>
-            </c:dLbl>
-            <c:dLbl>
-              <c:idx val="1"/>
-              <c:tx>
-                <c:rich>
-                  <a:bodyPr/>
-                  <a:lstStyle/>
-                  <a:p>
-                    <a:r>
-                      <a:rPr sz="950" b="1">
-                        <a:solidFill>
-                          <a:srgbClr val="1A1A1A"/>
-                        </a:solidFill>
-                      </a:rPr>
-                      <a:t>60%</a:t>
-                    </a:r>
-                  </a:p>
-                </c:rich>
-              </c:tx>
-              <c:dLblPos val="outEnd"/>
-              <c:showLegendKey val="0"/>
-              <c:showVal val="1"/>
-              <c:showCatName val="0"/>
-              <c:showSerName val="0"/>
-              <c:showPercent val="0"/>
-              <c:showBubbleSize val="0"/>
-            </c:dLbl>
-            <c:dLbl>
-              <c:idx val="2"/>
-              <c:tx>
-                <c:rich>
-                  <a:bodyPr/>
-                  <a:lstStyle/>
-                  <a:p>
-                    <a:r>
-                      <a:rPr sz="950" b="1">
-                        <a:solidFill>
-                          <a:srgbClr val="1A1A1A"/>
-                        </a:solidFill>
-                      </a:rPr>
-                      <a:t>75%</a:t>
-                    </a:r>
-                  </a:p>
-                </c:rich>
-              </c:tx>
-              <c:dLblPos val="outEnd"/>
-              <c:showLegendKey val="0"/>
-              <c:showVal val="1"/>
-              <c:showCatName val="0"/>
-              <c:showSerName val="0"/>
-              <c:showPercent val="0"/>
-              <c:showBubbleSize val="0"/>
-            </c:dLbl>
-            <c:dLbl>
-              <c:idx val="3"/>
-              <c:tx>
-                <c:rich>
-                  <a:bodyPr/>
-                  <a:lstStyle/>
-                  <a:p>
-                    <a:r>
-                      <a:rPr sz="950" b="1">
-                        <a:solidFill>
-                          <a:srgbClr val="1A1A1A"/>
-                        </a:solidFill>
-                      </a:rPr>
-                      <a:t>90%</a:t>
-                    </a:r>
-                  </a:p>
-                </c:rich>
-              </c:tx>
-              <c:dLblPos val="outEnd"/>
-              <c:showLegendKey val="0"/>
-              <c:showVal val="1"/>
-              <c:showCatName val="0"/>
-              <c:showSerName val="0"/>
-              <c:showPercent val="0"/>
-              <c:showBubbleSize val="0"/>
-            </c:dLbl>
-            <c:showLegendKey val="0"/>
-            <c:showVal val="0"/>
-            <c:showCatName val="0"/>
-            <c:showSerName val="0"/>
-            <c:showPercent val="0"/>
-            <c:showBubbleSize val="0"/>
-            <c:showLeaderLines val="1"/>
-          </c:dLbls>
-          <c:cat>
-            <c:strRef>
-              <c:f>Sheet1!$A$2:$A$5</c:f>
-              <c:strCache>
-                <c:ptCount val="4"/>
-                <c:pt idx="0">
-                  <c:v>2025</c:v>
-                </c:pt>
-                <c:pt idx="1">
-                  <c:v>2026</c:v>
-                </c:pt>
-                <c:pt idx="2">
-                  <c:v>2027</c:v>
-                </c:pt>
-                <c:pt idx="3">
-                  <c:v>2028</c:v>
-                </c:pt>
-              </c:strCache>
-            </c:strRef>
-          </c:cat>
-          <c:val>
-            <c:numRef>
-              <c:f>Sheet1!$B$2:$B$5</c:f>
-              <c:numCache>
-                <c:formatCode>General</c:formatCode>
-                <c:ptCount val="4"/>
-                <c:pt idx="0">
-                  <c:v>45</c:v>
-                </c:pt>
-                <c:pt idx="1">
-                  <c:v>60</c:v>
-                </c:pt>
-                <c:pt idx="2">
-                  <c:v>75</c:v>
-                </c:pt>
-                <c:pt idx="3">
-                  <c:v>90</c:v>
-                </c:pt>
-              </c:numCache>
-            </c:numRef>
-          </c:val>
-        </c:ser>
-        <c:gapWidth val="45"/>
-        <c:overlap val="-5"/>
-        <c:axId val="-2068027336"/>
-        <c:axId val="-2113994440"/>
-      </c:barChart>
-      <c:catAx>
-        <c:axId val="-2068027336"/>
-        <c:scaling>
-          <c:orientation val="minMax"/>
-        </c:scaling>
-        <c:delete val="0"/>
-        <c:axPos val="b"/>
-        <c:majorTickMark val="none"/>
-        <c:minorTickMark val="none"/>
-        <c:tickLblPos val="nextTo"/>
-        <c:spPr>
-          <a:ln w="9525">
-            <a:solidFill>
-              <a:srgbClr val="BFBFBF"/>
-            </a:solidFill>
-          </a:ln>
-        </c:spPr>
-        <c:txPr>
-          <a:bodyPr/>
-          <a:lstStyle/>
-          <a:p>
-            <a:pPr>
-              <a:defRPr sz="900">
-                <a:solidFill>
-                  <a:srgbClr val="595959"/>
-                </a:solidFill>
-              </a:defRPr>
-            </a:pPr>
-          </a:p>
-        </c:txPr>
-        <c:crossAx val="-2113994440"/>
-        <c:crosses val="autoZero"/>
-        <c:auto val="1"/>
-        <c:lblAlgn val="ctr"/>
-        <c:lblOffset val="100"/>
-        <c:noMultiLvlLbl val="0"/>
-      </c:catAx>
-      <c:valAx>
-        <c:axId val="-2113994440"/>
-        <c:scaling>
-          <c:max val="105.0"/>
-          <c:min val="0.0"/>
-        </c:scaling>
-        <c:delete/>
-        <c:axPos val="l"/>
-        <c:majorTickMark val="out"/>
-        <c:minorTickMark val="none"/>
-        <c:tickLblPos val="nextTo"/>
-        <c:crossAx val="-2068027336"/>
-        <c:crosses val="autoZero"/>
-      </c:valAx>
-    </c:plotArea>
-    <c:dispBlanksAs val="gap"/>
-  </c:chart>
-  <c:spPr>
-    <a:noFill/>
-    <a:ln>
-      <a:noFill/>
-    </a:ln>
-  </c:spPr>
-  <c:txPr>
-    <a:bodyPr/>
-    <a:lstStyle/>
-    <a:p>
-      <a:pPr>
-        <a:defRPr sz="900">
-          <a:solidFill>
-            <a:srgbClr val="595959"/>
-          </a:solidFill>
-          <a:latin typeface="Calibri"/>
-        </a:defRPr>
-      </a:pPr>
-      <a:endParaRPr lang="en-US"/>
-    </a:p>
-  </c:txPr>
-  <c:externalData r:id="rId1">
-    <c:autoUpdate val="0"/>
-  </c:externalData>
-</c:chartSpace>
-</file>
-
-<file path=ppt/charts/chart12.xml><?xml version="1.0" encoding="utf-8"?>
-<c:chartSpace xmlns:c="http://schemas.openxmlformats.org/drawingml/2006/chart" xmlns:a="http://schemas.openxmlformats.org/drawingml/2006/main" xmlns:r="http://schemas.openxmlformats.org/officeDocument/2006/relationships">
-  <c:date1904 val="0"/>
-  <c:chart>
-    <c:autoTitleDeleted val="1"/>
-    <c:plotArea>
       <c:lineChart>
         <c:grouping val="standard"/>
         <c:varyColors val="0"/>
@@ -1449,12 +973,12 @@
                   <a:lstStyle/>
                   <a:p>
                     <a:r>
-                      <a:rPr sz="1050" b="1">
+                      <a:rPr sz="1100" b="1">
                         <a:solidFill>
                           <a:srgbClr val="1A1A1A"/>
                         </a:solidFill>
                       </a:rPr>
-                      <a:t>12,95</a:t>
+                      <a:t>R$9,1 bi</a:t>
                     </a:r>
                   </a:p>
                 </c:rich>
@@ -1475,12 +999,12 @@
                   <a:lstStyle/>
                   <a:p>
                     <a:r>
-                      <a:rPr sz="1050" b="1">
+                      <a:rPr sz="1100" b="1">
                         <a:solidFill>
                           <a:srgbClr val="1A1A1A"/>
                         </a:solidFill>
                       </a:rPr>
-                      <a:t>~4,5</a:t>
+                      <a:t>R$3,4 bi</a:t>
                     </a:r>
                   </a:p>
                 </c:rich>
@@ -1501,12 +1025,12 @@
                   <a:lstStyle/>
                   <a:p>
                     <a:r>
-                      <a:rPr sz="1050" b="1">
+                      <a:rPr sz="1100" b="1">
                         <a:solidFill>
                           <a:srgbClr val="009F41"/>
                         </a:solidFill>
                       </a:rPr>
-                      <a:t>0,80</a:t>
+                      <a:t>R$0,18 bi</a:t>
                     </a:r>
                   </a:p>
                 </c:rich>
@@ -1533,13 +1057,13 @@
               <c:strCache>
                 <c:ptCount val="3"/>
                 <c:pt idx="0">
-                  <c:v>Hikvision</c:v>
+                  <c:v>Hikvision · 12,7% da receita</c:v>
                 </c:pt>
                 <c:pt idx="1">
-                  <c:v>Dahua</c:v>
+                  <c:v>Dahua · 13,2%</c:v>
                 </c:pt>
                 <c:pt idx="2">
-                  <c:v>Intelbras</c:v>
+                  <c:v>Intelbras · 4,0%</c:v>
                 </c:pt>
               </c:strCache>
             </c:strRef>
@@ -1551,13 +1075,13 @@
                 <c:formatCode>General</c:formatCode>
                 <c:ptCount val="3"/>
                 <c:pt idx="0">
-                  <c:v>12.95</c:v>
+                  <c:v>9.12</c:v>
                 </c:pt>
                 <c:pt idx="1">
-                  <c:v>4.5</c:v>
+                  <c:v>3.36</c:v>
                 </c:pt>
                 <c:pt idx="2">
-                  <c:v>0.8</c:v>
+                  <c:v>0.18</c:v>
                 </c:pt>
               </c:numCache>
             </c:numRef>
@@ -1605,7 +1129,7 @@
       <c:valAx>
         <c:axId val="-2113994440"/>
         <c:scaling>
-          <c:max val="17.0"/>
+          <c:max val="11.5"/>
           <c:min val="0.0"/>
         </c:scaling>
         <c:delete/>
@@ -1653,7 +1177,7 @@
     <c:autoTitleDeleted val="1"/>
     <c:plotArea>
       <c:barChart>
-        <c:barDir val="col"/>
+        <c:barDir val="bar"/>
         <c:grouping val="clustered"/>
         <c:ser>
           <c:idx val="0"/>
@@ -1664,17 +1188,35 @@
               <c:strCache>
                 <c:ptCount val="1"/>
                 <c:pt idx="0">
-                  <c:v>Maior problema</c:v>
+                  <c:v>v</c:v>
                 </c:pt>
               </c:strCache>
             </c:strRef>
           </c:tx>
-          <c:spPr>
-            <a:solidFill>
-              <a:srgbClr val="009F41"/>
-            </a:solidFill>
-          </c:spPr>
-          <c:invertIfNegative val="0"/>
+          <c:dPt>
+            <c:idx val="0"/>
+            <c:spPr>
+              <a:solidFill>
+                <a:srgbClr val="1A1A1A"/>
+              </a:solidFill>
+            </c:spPr>
+          </c:dPt>
+          <c:dPt>
+            <c:idx val="1"/>
+            <c:spPr>
+              <a:solidFill>
+                <a:srgbClr val="009F41"/>
+              </a:solidFill>
+            </c:spPr>
+          </c:dPt>
+          <c:dPt>
+            <c:idx val="2"/>
+            <c:spPr>
+              <a:solidFill>
+                <a:srgbClr val="BFBFBF"/>
+              </a:solidFill>
+            </c:spPr>
+          </c:dPt>
           <c:dLbls>
             <c:dLbl>
               <c:idx val="0"/>
@@ -1684,12 +1226,12 @@
                   <a:lstStyle/>
                   <a:p>
                     <a:r>
-                      <a:rPr sz="950" b="1">
+                      <a:rPr sz="1100" b="1">
                         <a:solidFill>
-                          <a:srgbClr val="009F41"/>
+                          <a:srgbClr val="1A1A1A"/>
                         </a:solidFill>
                       </a:rPr>
-                      <a:t>17%</a:t>
+                      <a:t>~12% a.a.</a:t>
                     </a:r>
                   </a:p>
                 </c:rich>
@@ -1710,12 +1252,12 @@
                   <a:lstStyle/>
                   <a:p>
                     <a:r>
-                      <a:rPr sz="950" b="1">
+                      <a:rPr sz="1100" b="1">
                         <a:solidFill>
                           <a:srgbClr val="009F41"/>
                         </a:solidFill>
                       </a:rPr>
-                      <a:t>38%</a:t>
+                      <a:t>+4,9%</a:t>
                     </a:r>
                   </a:p>
                 </c:rich>
@@ -1736,12 +1278,12 @@
                   <a:lstStyle/>
                   <a:p>
                     <a:r>
-                      <a:rPr sz="950" b="1">
+                      <a:rPr sz="1100" b="1">
                         <a:solidFill>
-                          <a:srgbClr val="009F41"/>
+                          <a:srgbClr val="595959"/>
                         </a:solidFill>
                       </a:rPr>
-                      <a:t>30%</a:t>
+                      <a:t>3,4% a.a.</a:t>
                     </a:r>
                   </a:p>
                 </c:rich>
@@ -1768,13 +1310,13 @@
               <c:strCache>
                 <c:ptCount val="3"/>
                 <c:pt idx="0">
-                  <c:v>out/24</c:v>
+                  <c:v>Cidades inteligentes</c:v>
                 </c:pt>
                 <c:pt idx="1">
-                  <c:v>nov/25</c:v>
+                  <c:v>Segurança Intelbras (2025)</c:v>
                 </c:pt>
                 <c:pt idx="2">
-                  <c:v>jun/26</c:v>
+                  <c:v>Videomonitoramento total</c:v>
                 </c:pt>
               </c:strCache>
             </c:strRef>
@@ -1786,38 +1328,35 @@
                 <c:formatCode>General</c:formatCode>
                 <c:ptCount val="3"/>
                 <c:pt idx="0">
-                  <c:v>17</c:v>
+                  <c:v>12</c:v>
                 </c:pt>
                 <c:pt idx="1">
-                  <c:v>38</c:v>
+                  <c:v>4.9</c:v>
                 </c:pt>
                 <c:pt idx="2">
-                  <c:v>30</c:v>
+                  <c:v>3.4</c:v>
                 </c:pt>
               </c:numCache>
             </c:numRef>
           </c:val>
         </c:ser>
-        <c:gapWidth val="50"/>
-        <c:overlap val="-5"/>
+        <c:gapWidth val="40"/>
         <c:axId val="-2068027336"/>
         <c:axId val="-2113994440"/>
       </c:barChart>
       <c:catAx>
         <c:axId val="-2068027336"/>
         <c:scaling>
-          <c:orientation val="minMax"/>
+          <c:orientation val="maxMin"/>
         </c:scaling>
         <c:delete val="0"/>
-        <c:axPos val="b"/>
+        <c:axPos val="l"/>
         <c:majorTickMark val="none"/>
         <c:minorTickMark val="none"/>
         <c:tickLblPos val="nextTo"/>
         <c:spPr>
           <a:ln w="9525">
-            <a:solidFill>
-              <a:srgbClr val="BFBFBF"/>
-            </a:solidFill>
+            <a:noFill/>
           </a:ln>
         </c:spPr>
         <c:txPr>
@@ -1843,11 +1382,11 @@
       <c:valAx>
         <c:axId val="-2113994440"/>
         <c:scaling>
-          <c:max val="46.0"/>
+          <c:max val="16.0"/>
           <c:min val="0.0"/>
         </c:scaling>
         <c:delete/>
-        <c:axPos val="l"/>
+        <c:axPos val="b"/>
         <c:majorTickMark val="out"/>
         <c:minorTickMark val="none"/>
         <c:tickLblPos val="nextTo"/>
@@ -1885,570 +1424,6 @@
 </file>
 
 <file path=ppt/charts/chart4.xml><?xml version="1.0" encoding="utf-8"?>
-<c:chartSpace xmlns:c="http://schemas.openxmlformats.org/drawingml/2006/chart" xmlns:a="http://schemas.openxmlformats.org/drawingml/2006/main" xmlns:r="http://schemas.openxmlformats.org/officeDocument/2006/relationships">
-  <c:date1904 val="0"/>
-  <c:chart>
-    <c:autoTitleDeleted val="1"/>
-    <c:plotArea>
-      <c:barChart>
-        <c:barDir val="col"/>
-        <c:grouping val="clustered"/>
-        <c:ser>
-          <c:idx val="0"/>
-          <c:order val="0"/>
-          <c:tx>
-            <c:strRef>
-              <c:f>Sheet1!$B$1</c:f>
-              <c:strCache>
-                <c:ptCount val="1"/>
-                <c:pt idx="0">
-                  <c:v>Share</c:v>
-                </c:pt>
-              </c:strCache>
-            </c:strRef>
-          </c:tx>
-          <c:spPr>
-            <a:solidFill>
-              <a:srgbClr val="009F41"/>
-            </a:solidFill>
-          </c:spPr>
-          <c:invertIfNegative val="0"/>
-          <c:dPt>
-            <c:idx val="0"/>
-            <c:spPr>
-              <a:solidFill>
-                <a:srgbClr val="BFBFBF"/>
-              </a:solidFill>
-            </c:spPr>
-          </c:dPt>
-          <c:dPt>
-            <c:idx val="1"/>
-            <c:spPr>
-              <a:solidFill>
-                <a:srgbClr val="BFBFBF"/>
-              </a:solidFill>
-            </c:spPr>
-          </c:dPt>
-          <c:dLbls>
-            <c:dLbl>
-              <c:idx val="0"/>
-              <c:tx>
-                <c:rich>
-                  <a:bodyPr/>
-                  <a:lstStyle/>
-                  <a:p>
-                    <a:r>
-                      <a:rPr sz="950" b="1">
-                        <a:solidFill>
-                          <a:srgbClr val="595959"/>
-                        </a:solidFill>
-                      </a:rPr>
-                      <a:t>43%</a:t>
-                    </a:r>
-                  </a:p>
-                </c:rich>
-              </c:tx>
-              <c:dLblPos val="outEnd"/>
-              <c:showLegendKey val="0"/>
-              <c:showVal val="1"/>
-              <c:showCatName val="0"/>
-              <c:showSerName val="0"/>
-              <c:showPercent val="0"/>
-              <c:showBubbleSize val="0"/>
-            </c:dLbl>
-            <c:dLbl>
-              <c:idx val="1"/>
-              <c:tx>
-                <c:rich>
-                  <a:bodyPr/>
-                  <a:lstStyle/>
-                  <a:p>
-                    <a:r>
-                      <a:rPr sz="950" b="1">
-                        <a:solidFill>
-                          <a:srgbClr val="595959"/>
-                        </a:solidFill>
-                      </a:rPr>
-                      <a:t>54%</a:t>
-                    </a:r>
-                  </a:p>
-                </c:rich>
-              </c:tx>
-              <c:dLblPos val="outEnd"/>
-              <c:showLegendKey val="0"/>
-              <c:showVal val="1"/>
-              <c:showCatName val="0"/>
-              <c:showSerName val="0"/>
-              <c:showPercent val="0"/>
-              <c:showBubbleSize val="0"/>
-            </c:dLbl>
-            <c:dLbl>
-              <c:idx val="2"/>
-              <c:tx>
-                <c:rich>
-                  <a:bodyPr/>
-                  <a:lstStyle/>
-                  <a:p>
-                    <a:r>
-                      <a:rPr sz="950" b="1">
-                        <a:solidFill>
-                          <a:srgbClr val="595959"/>
-                        </a:solidFill>
-                      </a:rPr>
-                      <a:t>43%</a:t>
-                    </a:r>
-                  </a:p>
-                </c:rich>
-              </c:tx>
-              <c:dLblPos val="outEnd"/>
-              <c:showLegendKey val="0"/>
-              <c:showVal val="1"/>
-              <c:showCatName val="0"/>
-              <c:showSerName val="0"/>
-              <c:showPercent val="0"/>
-              <c:showBubbleSize val="0"/>
-            </c:dLbl>
-            <c:dLbl>
-              <c:idx val="3"/>
-              <c:tx>
-                <c:rich>
-                  <a:bodyPr/>
-                  <a:lstStyle/>
-                  <a:p>
-                    <a:r>
-                      <a:rPr sz="950" b="1">
-                        <a:solidFill>
-                          <a:srgbClr val="595959"/>
-                        </a:solidFill>
-                      </a:rPr>
-                      <a:t>44%</a:t>
-                    </a:r>
-                  </a:p>
-                </c:rich>
-              </c:tx>
-              <c:dLblPos val="outEnd"/>
-              <c:showLegendKey val="0"/>
-              <c:showVal val="1"/>
-              <c:showCatName val="0"/>
-              <c:showSerName val="0"/>
-              <c:showPercent val="0"/>
-              <c:showBubbleSize val="0"/>
-            </c:dLbl>
-            <c:showLegendKey val="0"/>
-            <c:showVal val="0"/>
-            <c:showCatName val="0"/>
-            <c:showSerName val="0"/>
-            <c:showPercent val="0"/>
-            <c:showBubbleSize val="0"/>
-            <c:showLeaderLines val="1"/>
-          </c:dLbls>
-          <c:cat>
-            <c:strRef>
-              <c:f>Sheet1!$A$2:$A$5</c:f>
-              <c:strCache>
-                <c:ptCount val="4"/>
-                <c:pt idx="0">
-                  <c:v>2020
-CFTV</c:v>
-                </c:pt>
-                <c:pt idx="1">
-                  <c:v>c.2022
-CFTV</c:v>
-                </c:pt>
-                <c:pt idx="2">
-                  <c:v>2024
-segmento</c:v>
-                </c:pt>
-                <c:pt idx="3">
-                  <c:v>2025
-segmento</c:v>
-                </c:pt>
-              </c:strCache>
-            </c:strRef>
-          </c:cat>
-          <c:val>
-            <c:numRef>
-              <c:f>Sheet1!$B$2:$B$5</c:f>
-              <c:numCache>
-                <c:formatCode>General</c:formatCode>
-                <c:ptCount val="4"/>
-                <c:pt idx="0">
-                  <c:v>43</c:v>
-                </c:pt>
-                <c:pt idx="1">
-                  <c:v>54</c:v>
-                </c:pt>
-                <c:pt idx="2">
-                  <c:v>43</c:v>
-                </c:pt>
-                <c:pt idx="3">
-                  <c:v>44</c:v>
-                </c:pt>
-              </c:numCache>
-            </c:numRef>
-          </c:val>
-        </c:ser>
-        <c:gapWidth val="45"/>
-        <c:overlap val="-5"/>
-        <c:axId val="-2068027336"/>
-        <c:axId val="-2113994440"/>
-      </c:barChart>
-      <c:catAx>
-        <c:axId val="-2068027336"/>
-        <c:scaling>
-          <c:orientation val="minMax"/>
-        </c:scaling>
-        <c:delete val="0"/>
-        <c:axPos val="b"/>
-        <c:majorTickMark val="none"/>
-        <c:minorTickMark val="none"/>
-        <c:tickLblPos val="nextTo"/>
-        <c:spPr>
-          <a:ln w="9525">
-            <a:solidFill>
-              <a:srgbClr val="BFBFBF"/>
-            </a:solidFill>
-          </a:ln>
-        </c:spPr>
-        <c:txPr>
-          <a:bodyPr/>
-          <a:lstStyle/>
-          <a:p>
-            <a:pPr>
-              <a:defRPr sz="850">
-                <a:solidFill>
-                  <a:srgbClr val="595959"/>
-                </a:solidFill>
-              </a:defRPr>
-            </a:pPr>
-          </a:p>
-        </c:txPr>
-        <c:crossAx val="-2113994440"/>
-        <c:crosses val="autoZero"/>
-        <c:auto val="1"/>
-        <c:lblAlgn val="ctr"/>
-        <c:lblOffset val="100"/>
-        <c:noMultiLvlLbl val="0"/>
-      </c:catAx>
-      <c:valAx>
-        <c:axId val="-2113994440"/>
-        <c:scaling>
-          <c:max val="65.0"/>
-          <c:min val="0.0"/>
-        </c:scaling>
-        <c:delete/>
-        <c:axPos val="l"/>
-        <c:majorTickMark val="out"/>
-        <c:minorTickMark val="none"/>
-        <c:tickLblPos val="nextTo"/>
-        <c:crossAx val="-2068027336"/>
-        <c:crosses val="autoZero"/>
-      </c:valAx>
-    </c:plotArea>
-    <c:dispBlanksAs val="gap"/>
-  </c:chart>
-  <c:spPr>
-    <a:noFill/>
-    <a:ln>
-      <a:noFill/>
-    </a:ln>
-  </c:spPr>
-  <c:txPr>
-    <a:bodyPr/>
-    <a:lstStyle/>
-    <a:p>
-      <a:pPr>
-        <a:defRPr sz="850">
-          <a:solidFill>
-            <a:srgbClr val="595959"/>
-          </a:solidFill>
-          <a:latin typeface="Calibri"/>
-        </a:defRPr>
-      </a:pPr>
-      <a:endParaRPr lang="en-US"/>
-    </a:p>
-  </c:txPr>
-  <c:externalData r:id="rId1">
-    <c:autoUpdate val="0"/>
-  </c:externalData>
-</c:chartSpace>
-</file>
-
-<file path=ppt/charts/chart5.xml><?xml version="1.0" encoding="utf-8"?>
-<c:chartSpace xmlns:c="http://schemas.openxmlformats.org/drawingml/2006/chart" xmlns:a="http://schemas.openxmlformats.org/drawingml/2006/main" xmlns:r="http://schemas.openxmlformats.org/officeDocument/2006/relationships">
-  <c:date1904 val="0"/>
-  <c:chart>
-    <c:autoTitleDeleted val="1"/>
-    <c:plotArea>
-      <c:lineChart>
-        <c:grouping val="standard"/>
-        <c:varyColors val="0"/>
-        <c:ser>
-          <c:idx val="0"/>
-          <c:order val="0"/>
-          <c:tx>
-            <c:strRef>
-              <c:f>Sheet1!$B$1</c:f>
-              <c:strCache>
-                <c:ptCount val="1"/>
-                <c:pt idx="0">
-                  <c:v>Margem bruta</c:v>
-                </c:pt>
-              </c:strCache>
-            </c:strRef>
-          </c:tx>
-          <c:spPr>
-            <a:ln w="28575">
-              <a:solidFill>
-                <a:srgbClr val="1A1A1A"/>
-              </a:solidFill>
-            </a:ln>
-          </c:spPr>
-          <c:marker>
-            <c:symbol val="circle"/>
-            <c:size val="6"/>
-            <c:spPr>
-              <a:solidFill>
-                <a:srgbClr val="1A1A1A"/>
-              </a:solidFill>
-              <a:ln>
-                <a:solidFill>
-                  <a:srgbClr val="1A1A1A"/>
-                </a:solidFill>
-              </a:ln>
-            </c:spPr>
-          </c:marker>
-          <c:dLbls>
-            <c:dLbl>
-              <c:idx val="0"/>
-              <c:tx>
-                <c:rich>
-                  <a:bodyPr/>
-                  <a:lstStyle/>
-                  <a:p>
-                    <a:r>
-                      <a:rPr sz="900" b="1">
-                        <a:solidFill>
-                          <a:srgbClr val="1A1A1A"/>
-                        </a:solidFill>
-                      </a:rPr>
-                      <a:t>36,5%</a:t>
-                    </a:r>
-                  </a:p>
-                </c:rich>
-              </c:tx>
-              <c:dLblPos val="t"/>
-              <c:showLegendKey val="0"/>
-              <c:showVal val="1"/>
-              <c:showCatName val="0"/>
-              <c:showSerName val="0"/>
-              <c:showPercent val="0"/>
-              <c:showBubbleSize val="0"/>
-            </c:dLbl>
-            <c:dLbl>
-              <c:idx val="3"/>
-              <c:tx>
-                <c:rich>
-                  <a:bodyPr/>
-                  <a:lstStyle/>
-                  <a:p>
-                    <a:r>
-                      <a:rPr sz="900" b="1">
-                        <a:solidFill>
-                          <a:srgbClr val="1A1A1A"/>
-                        </a:solidFill>
-                      </a:rPr>
-                      <a:t>37,4%</a:t>
-                    </a:r>
-                  </a:p>
-                </c:rich>
-              </c:tx>
-              <c:dLblPos val="t"/>
-              <c:showLegendKey val="0"/>
-              <c:showVal val="1"/>
-              <c:showCatName val="0"/>
-              <c:showSerName val="0"/>
-              <c:showPercent val="0"/>
-              <c:showBubbleSize val="0"/>
-            </c:dLbl>
-            <c:dLbl>
-              <c:idx val="5"/>
-              <c:tx>
-                <c:rich>
-                  <a:bodyPr/>
-                  <a:lstStyle/>
-                  <a:p>
-                    <a:r>
-                      <a:rPr sz="900" b="1">
-                        <a:solidFill>
-                          <a:srgbClr val="1A1A1A"/>
-                        </a:solidFill>
-                      </a:rPr>
-                      <a:t>33,2%</a:t>
-                    </a:r>
-                  </a:p>
-                </c:rich>
-              </c:tx>
-              <c:dLblPos val="t"/>
-              <c:showLegendKey val="0"/>
-              <c:showVal val="1"/>
-              <c:showCatName val="0"/>
-              <c:showSerName val="0"/>
-              <c:showPercent val="0"/>
-              <c:showBubbleSize val="0"/>
-            </c:dLbl>
-            <c:showLegendKey val="0"/>
-            <c:showVal val="0"/>
-            <c:showCatName val="0"/>
-            <c:showSerName val="0"/>
-            <c:showPercent val="0"/>
-            <c:showBubbleSize val="0"/>
-            <c:showLeaderLines val="1"/>
-          </c:dLbls>
-          <c:cat>
-            <c:strRef>
-              <c:f>Sheet1!$A$2:$A$7</c:f>
-              <c:strCache>
-                <c:ptCount val="6"/>
-                <c:pt idx="0">
-                  <c:v>2020</c:v>
-                </c:pt>
-                <c:pt idx="1">
-                  <c:v>2021</c:v>
-                </c:pt>
-                <c:pt idx="2">
-                  <c:v>2022</c:v>
-                </c:pt>
-                <c:pt idx="3">
-                  <c:v>2023</c:v>
-                </c:pt>
-                <c:pt idx="4">
-                  <c:v>2024</c:v>
-                </c:pt>
-                <c:pt idx="5">
-                  <c:v>2025</c:v>
-                </c:pt>
-              </c:strCache>
-            </c:strRef>
-          </c:cat>
-          <c:val>
-            <c:numRef>
-              <c:f>Sheet1!$B$2:$B$7</c:f>
-              <c:numCache>
-                <c:formatCode>General</c:formatCode>
-                <c:ptCount val="6"/>
-                <c:pt idx="0">
-                  <c:v>36.5</c:v>
-                </c:pt>
-                <c:pt idx="1">
-                  <c:v>34.1</c:v>
-                </c:pt>
-                <c:pt idx="2">
-                  <c:v>34.5</c:v>
-                </c:pt>
-                <c:pt idx="3">
-                  <c:v>37.4</c:v>
-                </c:pt>
-                <c:pt idx="4">
-                  <c:v>34.8</c:v>
-                </c:pt>
-                <c:pt idx="5">
-                  <c:v>33.2</c:v>
-                </c:pt>
-              </c:numCache>
-            </c:numRef>
-          </c:val>
-          <c:smooth val="0"/>
-        </c:ser>
-        <c:marker val="1"/>
-        <c:smooth val="0"/>
-        <c:axId val="2118791784"/>
-        <c:axId val="2140495176"/>
-      </c:lineChart>
-      <c:catAx>
-        <c:axId val="2118791784"/>
-        <c:scaling>
-          <c:orientation val="minMax"/>
-        </c:scaling>
-        <c:delete val="0"/>
-        <c:axPos val="b"/>
-        <c:majorTickMark val="none"/>
-        <c:minorTickMark val="none"/>
-        <c:tickLblPos val="nextTo"/>
-        <c:spPr>
-          <a:ln w="9525">
-            <a:solidFill>
-              <a:srgbClr val="BFBFBF"/>
-            </a:solidFill>
-          </a:ln>
-        </c:spPr>
-        <c:txPr>
-          <a:bodyPr/>
-          <a:lstStyle/>
-          <a:p>
-            <a:pPr>
-              <a:defRPr sz="850">
-                <a:solidFill>
-                  <a:srgbClr val="595959"/>
-                </a:solidFill>
-              </a:defRPr>
-            </a:pPr>
-          </a:p>
-        </c:txPr>
-        <c:crossAx val="2140495176"/>
-        <c:crosses val="autoZero"/>
-        <c:auto val="1"/>
-        <c:lblAlgn val="ctr"/>
-        <c:lblOffset val="100"/>
-        <c:noMultiLvlLbl val="0"/>
-      </c:catAx>
-      <c:valAx>
-        <c:axId val="2140495176"/>
-        <c:scaling>
-          <c:max val="40.0"/>
-          <c:min val="28.0"/>
-        </c:scaling>
-        <c:delete/>
-        <c:axPos val="l"/>
-        <c:majorTickMark val="out"/>
-        <c:minorTickMark val="none"/>
-        <c:tickLblPos val="nextTo"/>
-        <c:crossAx val="2118791784"/>
-        <c:crosses val="autoZero"/>
-      </c:valAx>
-    </c:plotArea>
-    <c:plotVisOnly val="1"/>
-    <c:dispBlanksAs val="gap"/>
-    <c:showDLblsOverMax val="0"/>
-  </c:chart>
-  <c:spPr>
-    <a:noFill/>
-    <a:ln>
-      <a:noFill/>
-    </a:ln>
-  </c:spPr>
-  <c:txPr>
-    <a:bodyPr/>
-    <a:lstStyle/>
-    <a:p>
-      <a:pPr>
-        <a:defRPr sz="850">
-          <a:solidFill>
-            <a:srgbClr val="595959"/>
-          </a:solidFill>
-          <a:latin typeface="Calibri"/>
-        </a:defRPr>
-      </a:pPr>
-      <a:endParaRPr lang="en-US"/>
-    </a:p>
-  </c:txPr>
-  <c:externalData r:id="rId1">
-    <c:autoUpdate val="0"/>
-  </c:externalData>
-</c:chartSpace>
-</file>
-
-<file path=ppt/charts/chart6.xml><?xml version="1.0" encoding="utf-8"?>
 <c:chartSpace xmlns:c="http://schemas.openxmlformats.org/drawingml/2006/chart" xmlns:a="http://schemas.openxmlformats.org/drawingml/2006/main" xmlns:r="http://schemas.openxmlformats.org/officeDocument/2006/relationships">
   <c:date1904 val="0"/>
   <c:chart>
@@ -2822,7 +1797,7 @@
 </c:chartSpace>
 </file>
 
-<file path=ppt/charts/chart7.xml><?xml version="1.0" encoding="utf-8"?>
+<file path=ppt/charts/chart5.xml><?xml version="1.0" encoding="utf-8"?>
 <c:chartSpace xmlns:c="http://schemas.openxmlformats.org/drawingml/2006/chart" xmlns:a="http://schemas.openxmlformats.org/drawingml/2006/main" xmlns:r="http://schemas.openxmlformats.org/officeDocument/2006/relationships">
   <c:date1904 val="0"/>
   <c:chart>
@@ -3174,7 +2149,7 @@
 </c:chartSpace>
 </file>
 
-<file path=ppt/charts/chart8.xml><?xml version="1.0" encoding="utf-8"?>
+<file path=ppt/charts/chart6.xml><?xml version="1.0" encoding="utf-8"?>
 <c:chartSpace xmlns:c="http://schemas.openxmlformats.org/drawingml/2006/chart" xmlns:a="http://schemas.openxmlformats.org/drawingml/2006/main" xmlns:r="http://schemas.openxmlformats.org/officeDocument/2006/relationships">
   <c:date1904 val="0"/>
   <c:chart>
@@ -3548,7 +2523,7 @@
 </c:chartSpace>
 </file>
 
-<file path=ppt/charts/chart9.xml><?xml version="1.0" encoding="utf-8"?>
+<file path=ppt/charts/chart7.xml><?xml version="1.0" encoding="utf-8"?>
 <c:chartSpace xmlns:c="http://schemas.openxmlformats.org/drawingml/2006/chart" xmlns:a="http://schemas.openxmlformats.org/drawingml/2006/main" xmlns:r="http://schemas.openxmlformats.org/officeDocument/2006/relationships">
   <c:date1904 val="0"/>
   <c:chart>
@@ -3761,6 +2736,482 @@
 </c:chartSpace>
 </file>
 
+<file path=ppt/charts/chart8.xml><?xml version="1.0" encoding="utf-8"?>
+<c:chartSpace xmlns:c="http://schemas.openxmlformats.org/drawingml/2006/chart" xmlns:a="http://schemas.openxmlformats.org/drawingml/2006/main" xmlns:r="http://schemas.openxmlformats.org/officeDocument/2006/relationships">
+  <c:date1904 val="0"/>
+  <c:chart>
+    <c:autoTitleDeleted val="1"/>
+    <c:plotArea>
+      <c:barChart>
+        <c:barDir val="col"/>
+        <c:grouping val="clustered"/>
+        <c:ser>
+          <c:idx val="0"/>
+          <c:order val="0"/>
+          <c:tx>
+            <c:strRef>
+              <c:f>Sheet1!$B$1</c:f>
+              <c:strCache>
+                <c:ptCount val="1"/>
+                <c:pt idx="0">
+                  <c:v>GW</c:v>
+                </c:pt>
+              </c:strCache>
+            </c:strRef>
+          </c:tx>
+          <c:spPr>
+            <a:solidFill>
+              <a:srgbClr val="595959"/>
+            </a:solidFill>
+          </c:spPr>
+          <c:invertIfNegative val="0"/>
+          <c:dLbls>
+            <c:dLbl>
+              <c:idx val="0"/>
+              <c:tx>
+                <c:rich>
+                  <a:bodyPr/>
+                  <a:lstStyle/>
+                  <a:p>
+                    <a:r>
+                      <a:rPr sz="950" b="1">
+                        <a:solidFill>
+                          <a:srgbClr val="595959"/>
+                        </a:solidFill>
+                      </a:rPr>
+                      <a:t>15,0</a:t>
+                    </a:r>
+                  </a:p>
+                </c:rich>
+              </c:tx>
+              <c:dLblPos val="outEnd"/>
+              <c:showLegendKey val="0"/>
+              <c:showVal val="1"/>
+              <c:showCatName val="0"/>
+              <c:showSerName val="0"/>
+              <c:showPercent val="0"/>
+              <c:showBubbleSize val="0"/>
+            </c:dLbl>
+            <c:dLbl>
+              <c:idx val="1"/>
+              <c:tx>
+                <c:rich>
+                  <a:bodyPr/>
+                  <a:lstStyle/>
+                  <a:p>
+                    <a:r>
+                      <a:rPr sz="950" b="1">
+                        <a:solidFill>
+                          <a:srgbClr val="595959"/>
+                        </a:solidFill>
+                      </a:rPr>
+                      <a:t>10,6</a:t>
+                    </a:r>
+                  </a:p>
+                </c:rich>
+              </c:tx>
+              <c:dLblPos val="outEnd"/>
+              <c:showLegendKey val="0"/>
+              <c:showVal val="1"/>
+              <c:showCatName val="0"/>
+              <c:showSerName val="0"/>
+              <c:showPercent val="0"/>
+              <c:showBubbleSize val="0"/>
+            </c:dLbl>
+            <c:showLegendKey val="0"/>
+            <c:showVal val="0"/>
+            <c:showCatName val="0"/>
+            <c:showSerName val="0"/>
+            <c:showPercent val="0"/>
+            <c:showBubbleSize val="0"/>
+            <c:showLeaderLines val="1"/>
+          </c:dLbls>
+          <c:cat>
+            <c:strRef>
+              <c:f>Sheet1!$A$2:$A$3</c:f>
+              <c:strCache>
+                <c:ptCount val="2"/>
+                <c:pt idx="0">
+                  <c:v>2024</c:v>
+                </c:pt>
+                <c:pt idx="1">
+                  <c:v>2025</c:v>
+                </c:pt>
+              </c:strCache>
+            </c:strRef>
+          </c:cat>
+          <c:val>
+            <c:numRef>
+              <c:f>Sheet1!$B$2:$B$3</c:f>
+              <c:numCache>
+                <c:formatCode>General</c:formatCode>
+                <c:ptCount val="2"/>
+                <c:pt idx="0">
+                  <c:v>15.0</c:v>
+                </c:pt>
+                <c:pt idx="1">
+                  <c:v>10.6</c:v>
+                </c:pt>
+              </c:numCache>
+            </c:numRef>
+          </c:val>
+        </c:ser>
+        <c:gapWidth val="50"/>
+        <c:overlap val="-5"/>
+        <c:axId val="-2068027336"/>
+        <c:axId val="-2113994440"/>
+      </c:barChart>
+      <c:catAx>
+        <c:axId val="-2068027336"/>
+        <c:scaling>
+          <c:orientation val="minMax"/>
+        </c:scaling>
+        <c:delete val="0"/>
+        <c:axPos val="b"/>
+        <c:majorTickMark val="none"/>
+        <c:minorTickMark val="none"/>
+        <c:tickLblPos val="nextTo"/>
+        <c:spPr>
+          <a:ln w="9525">
+            <a:solidFill>
+              <a:srgbClr val="BFBFBF"/>
+            </a:solidFill>
+          </a:ln>
+        </c:spPr>
+        <c:txPr>
+          <a:bodyPr/>
+          <a:lstStyle/>
+          <a:p>
+            <a:pPr>
+              <a:defRPr sz="900">
+                <a:solidFill>
+                  <a:srgbClr val="595959"/>
+                </a:solidFill>
+              </a:defRPr>
+            </a:pPr>
+          </a:p>
+        </c:txPr>
+        <c:crossAx val="-2113994440"/>
+        <c:crosses val="autoZero"/>
+        <c:auto val="1"/>
+        <c:lblAlgn val="ctr"/>
+        <c:lblOffset val="100"/>
+        <c:noMultiLvlLbl val="0"/>
+      </c:catAx>
+      <c:valAx>
+        <c:axId val="-2113994440"/>
+        <c:scaling>
+          <c:max val="18.0"/>
+          <c:min val="0.0"/>
+        </c:scaling>
+        <c:delete/>
+        <c:axPos val="l"/>
+        <c:majorTickMark val="out"/>
+        <c:minorTickMark val="none"/>
+        <c:tickLblPos val="nextTo"/>
+        <c:crossAx val="-2068027336"/>
+        <c:crosses val="autoZero"/>
+      </c:valAx>
+    </c:plotArea>
+    <c:dispBlanksAs val="gap"/>
+  </c:chart>
+  <c:spPr>
+    <a:noFill/>
+    <a:ln>
+      <a:noFill/>
+    </a:ln>
+  </c:spPr>
+  <c:txPr>
+    <a:bodyPr/>
+    <a:lstStyle/>
+    <a:p>
+      <a:pPr>
+        <a:defRPr sz="900">
+          <a:solidFill>
+            <a:srgbClr val="595959"/>
+          </a:solidFill>
+          <a:latin typeface="Calibri"/>
+        </a:defRPr>
+      </a:pPr>
+      <a:endParaRPr lang="en-US"/>
+    </a:p>
+  </c:txPr>
+  <c:externalData r:id="rId1">
+    <c:autoUpdate val="0"/>
+  </c:externalData>
+</c:chartSpace>
+</file>
+
+<file path=ppt/charts/chart9.xml><?xml version="1.0" encoding="utf-8"?>
+<c:chartSpace xmlns:c="http://schemas.openxmlformats.org/drawingml/2006/chart" xmlns:a="http://schemas.openxmlformats.org/drawingml/2006/main" xmlns:r="http://schemas.openxmlformats.org/officeDocument/2006/relationships">
+  <c:date1904 val="0"/>
+  <c:chart>
+    <c:autoTitleDeleted val="1"/>
+    <c:plotArea>
+      <c:barChart>
+        <c:barDir val="col"/>
+        <c:grouping val="clustered"/>
+        <c:ser>
+          <c:idx val="0"/>
+          <c:order val="0"/>
+          <c:tx>
+            <c:strRef>
+              <c:f>Sheet1!$B$1</c:f>
+              <c:strCache>
+                <c:ptCount val="1"/>
+                <c:pt idx="0">
+                  <c:v>Fio B</c:v>
+                </c:pt>
+              </c:strCache>
+            </c:strRef>
+          </c:tx>
+          <c:spPr>
+            <a:solidFill>
+              <a:srgbClr val="1A1A1A"/>
+            </a:solidFill>
+          </c:spPr>
+          <c:invertIfNegative val="0"/>
+          <c:dLbls>
+            <c:dLbl>
+              <c:idx val="0"/>
+              <c:tx>
+                <c:rich>
+                  <a:bodyPr/>
+                  <a:lstStyle/>
+                  <a:p>
+                    <a:r>
+                      <a:rPr sz="950" b="1">
+                        <a:solidFill>
+                          <a:srgbClr val="1A1A1A"/>
+                        </a:solidFill>
+                      </a:rPr>
+                      <a:t>45%</a:t>
+                    </a:r>
+                  </a:p>
+                </c:rich>
+              </c:tx>
+              <c:dLblPos val="outEnd"/>
+              <c:showLegendKey val="0"/>
+              <c:showVal val="1"/>
+              <c:showCatName val="0"/>
+              <c:showSerName val="0"/>
+              <c:showPercent val="0"/>
+              <c:showBubbleSize val="0"/>
+            </c:dLbl>
+            <c:dLbl>
+              <c:idx val="1"/>
+              <c:tx>
+                <c:rich>
+                  <a:bodyPr/>
+                  <a:lstStyle/>
+                  <a:p>
+                    <a:r>
+                      <a:rPr sz="950" b="1">
+                        <a:solidFill>
+                          <a:srgbClr val="1A1A1A"/>
+                        </a:solidFill>
+                      </a:rPr>
+                      <a:t>60%</a:t>
+                    </a:r>
+                  </a:p>
+                </c:rich>
+              </c:tx>
+              <c:dLblPos val="outEnd"/>
+              <c:showLegendKey val="0"/>
+              <c:showVal val="1"/>
+              <c:showCatName val="0"/>
+              <c:showSerName val="0"/>
+              <c:showPercent val="0"/>
+              <c:showBubbleSize val="0"/>
+            </c:dLbl>
+            <c:dLbl>
+              <c:idx val="2"/>
+              <c:tx>
+                <c:rich>
+                  <a:bodyPr/>
+                  <a:lstStyle/>
+                  <a:p>
+                    <a:r>
+                      <a:rPr sz="950" b="1">
+                        <a:solidFill>
+                          <a:srgbClr val="1A1A1A"/>
+                        </a:solidFill>
+                      </a:rPr>
+                      <a:t>75%</a:t>
+                    </a:r>
+                  </a:p>
+                </c:rich>
+              </c:tx>
+              <c:dLblPos val="outEnd"/>
+              <c:showLegendKey val="0"/>
+              <c:showVal val="1"/>
+              <c:showCatName val="0"/>
+              <c:showSerName val="0"/>
+              <c:showPercent val="0"/>
+              <c:showBubbleSize val="0"/>
+            </c:dLbl>
+            <c:dLbl>
+              <c:idx val="3"/>
+              <c:tx>
+                <c:rich>
+                  <a:bodyPr/>
+                  <a:lstStyle/>
+                  <a:p>
+                    <a:r>
+                      <a:rPr sz="950" b="1">
+                        <a:solidFill>
+                          <a:srgbClr val="1A1A1A"/>
+                        </a:solidFill>
+                      </a:rPr>
+                      <a:t>90%</a:t>
+                    </a:r>
+                  </a:p>
+                </c:rich>
+              </c:tx>
+              <c:dLblPos val="outEnd"/>
+              <c:showLegendKey val="0"/>
+              <c:showVal val="1"/>
+              <c:showCatName val="0"/>
+              <c:showSerName val="0"/>
+              <c:showPercent val="0"/>
+              <c:showBubbleSize val="0"/>
+            </c:dLbl>
+            <c:showLegendKey val="0"/>
+            <c:showVal val="0"/>
+            <c:showCatName val="0"/>
+            <c:showSerName val="0"/>
+            <c:showPercent val="0"/>
+            <c:showBubbleSize val="0"/>
+            <c:showLeaderLines val="1"/>
+          </c:dLbls>
+          <c:cat>
+            <c:strRef>
+              <c:f>Sheet1!$A$2:$A$5</c:f>
+              <c:strCache>
+                <c:ptCount val="4"/>
+                <c:pt idx="0">
+                  <c:v>2025</c:v>
+                </c:pt>
+                <c:pt idx="1">
+                  <c:v>2026</c:v>
+                </c:pt>
+                <c:pt idx="2">
+                  <c:v>2027</c:v>
+                </c:pt>
+                <c:pt idx="3">
+                  <c:v>2028</c:v>
+                </c:pt>
+              </c:strCache>
+            </c:strRef>
+          </c:cat>
+          <c:val>
+            <c:numRef>
+              <c:f>Sheet1!$B$2:$B$5</c:f>
+              <c:numCache>
+                <c:formatCode>General</c:formatCode>
+                <c:ptCount val="4"/>
+                <c:pt idx="0">
+                  <c:v>45</c:v>
+                </c:pt>
+                <c:pt idx="1">
+                  <c:v>60</c:v>
+                </c:pt>
+                <c:pt idx="2">
+                  <c:v>75</c:v>
+                </c:pt>
+                <c:pt idx="3">
+                  <c:v>90</c:v>
+                </c:pt>
+              </c:numCache>
+            </c:numRef>
+          </c:val>
+        </c:ser>
+        <c:gapWidth val="45"/>
+        <c:overlap val="-5"/>
+        <c:axId val="-2068027336"/>
+        <c:axId val="-2113994440"/>
+      </c:barChart>
+      <c:catAx>
+        <c:axId val="-2068027336"/>
+        <c:scaling>
+          <c:orientation val="minMax"/>
+        </c:scaling>
+        <c:delete val="0"/>
+        <c:axPos val="b"/>
+        <c:majorTickMark val="none"/>
+        <c:minorTickMark val="none"/>
+        <c:tickLblPos val="nextTo"/>
+        <c:spPr>
+          <a:ln w="9525">
+            <a:solidFill>
+              <a:srgbClr val="BFBFBF"/>
+            </a:solidFill>
+          </a:ln>
+        </c:spPr>
+        <c:txPr>
+          <a:bodyPr/>
+          <a:lstStyle/>
+          <a:p>
+            <a:pPr>
+              <a:defRPr sz="900">
+                <a:solidFill>
+                  <a:srgbClr val="595959"/>
+                </a:solidFill>
+              </a:defRPr>
+            </a:pPr>
+          </a:p>
+        </c:txPr>
+        <c:crossAx val="-2113994440"/>
+        <c:crosses val="autoZero"/>
+        <c:auto val="1"/>
+        <c:lblAlgn val="ctr"/>
+        <c:lblOffset val="100"/>
+        <c:noMultiLvlLbl val="0"/>
+      </c:catAx>
+      <c:valAx>
+        <c:axId val="-2113994440"/>
+        <c:scaling>
+          <c:max val="105.0"/>
+          <c:min val="0.0"/>
+        </c:scaling>
+        <c:delete/>
+        <c:axPos val="l"/>
+        <c:majorTickMark val="out"/>
+        <c:minorTickMark val="none"/>
+        <c:tickLblPos val="nextTo"/>
+        <c:crossAx val="-2068027336"/>
+        <c:crosses val="autoZero"/>
+      </c:valAx>
+    </c:plotArea>
+    <c:dispBlanksAs val="gap"/>
+  </c:chart>
+  <c:spPr>
+    <a:noFill/>
+    <a:ln>
+      <a:noFill/>
+    </a:ln>
+  </c:spPr>
+  <c:txPr>
+    <a:bodyPr/>
+    <a:lstStyle/>
+    <a:p>
+      <a:pPr>
+        <a:defRPr sz="900">
+          <a:solidFill>
+            <a:srgbClr val="595959"/>
+          </a:solidFill>
+          <a:latin typeface="Calibri"/>
+        </a:defRPr>
+      </a:pPr>
+      <a:endParaRPr lang="en-US"/>
+    </a:p>
+  </c:txPr>
+  <c:externalData r:id="rId1">
+    <c:autoUpdate val="0"/>
+  </c:externalData>
+</c:chartSpace>
+</file>
+
 <file path=ppt/notesMasters/notesMaster1.xml><?xml version="1.0" encoding="utf-8"?>
 <p:notesMaster xmlns:a="http://schemas.openxmlformats.org/drawingml/2006/main" xmlns:r="http://schemas.openxmlformats.org/officeDocument/2006/relationships" xmlns:p="http://schemas.openxmlformats.org/presentationml/2006/main">
   <p:cSld>
@@ -4161,32 +3612,32 @@
           <a:p/>
           <a:p>
             <a:r>
-              <a:t>ABERTURA: "Segurança é o coração da Intelbras e o único negócio que cria valor."</a:t>
-            </a:r>
-          </a:p>
-          <a:p>
-            <a:r>
-              <a:t>I. (colunas, depois os números) "A receita quase triplicou desde 2019: 18% ao ano. É 61% da receita e dois terços do lucro bruto, com retorno de ~28% sobre o capital, o dobro da Selic. Mas metade desse retorno é o incentivo de ICMS de Manaus: sem ele, cai para ~15%."</a:t>
-            </a:r>
-          </a:p>
-          <a:p>
-            <a:r>
-              <a:t>II. (barras, depois a lista) "Os rivais são gigantes: a Hikvision fatura 16 vezes mais e já monta em Manaus, pela Multilaser, com o mesmo regime fiscal. Em cada nicho há um rival diferente: Control iD em controle de acesso, JFL em alarmes, PPA e Garen em portões, e no varejo a TP-Link, a Xiaomi e até a Imou, marca da Dahua, chegando sem imposto pelo cross-border."</a:t>
-            </a:r>
-          </a:p>
-          <a:p>
-            <a:r>
-              <a:t>III. (percepção, depois as caixas) "A demanda segue a percepção de risco, não o crime: as mortes violentas caem, mas a segurança virou a maior preocupação do país. O motor de verdade é a obra, que vira instalação em 2027–28, e o retrofit dos 13 milhões de unidades em condomínio."</a:t>
-            </a:r>
-          </a:p>
-          <a:p>
-            <a:r>
-              <a:t>IV. (share, depois margem) "E a posição: o share está estável, em 43–44%. A série antiga media só CFTV, então não dá para dizer que ela ganhou share. A receita cresceu com o mercado, e a margem caiu: o share foi defendido com preço."</a:t>
-            </a:r>
-          </a:p>
-          <a:p>
-            <a:r>
-              <a:t>FECHO: "Segurança vale pelo canal e por Manaus, não por crescer mais que o mercado."</a:t>
+              <a:t>ABERTURA: "Em Segurança, a Intelbras é líder num mercado e coadjuvante em outro."</a:t>
+            </a:r>
+          </a:p>
+          <a:p>
+            <a:r>
+              <a:t>I. (colunas, depois os números) "Onde ela é forte: o mercado do instalador. A receita quase triplicou desde 2019, o share é de 44% e o retorno de ~28%. Dois terços das vendas passam por distribuidores e instaladores: é aí que o canal dela vence."</a:t>
+            </a:r>
+          </a:p>
+          <a:p>
+            <a:r>
+              <a:t>II. (barras) "Mas os rivais jogam outro jogo. A Hikvision gastou R$9 bilhões em P&amp;D em 2025, 51 vezes a Intelbras; a Dahua, R$3,4 bilhões, 19 vezes. As duas reinvestem ~13% da receita; a Intelbras, 4%. E juntas têm um terço do mercado mundial de vídeo."</a:t>
+            </a:r>
+          </a:p>
+          <a:p>
+            <a:r>
+              <a:t>III. (barras, depois os números) "E o driver que mais cresce é justamente o que exige esse P&amp;D: cidades inteligentes, ~12% ao ano, contra 3% do videomonitoramento total. São programas enormes: 94 mil câmeras no Muralha Paulista, 40 mil no Smart Sampa, 92 municípios no plano do Rio. O que se compra ali é reconhecimento facial, leitura de placas, inteligência artificial e centrais de comando."</a:t>
+            </a:r>
+          </a:p>
+          <a:p>
+            <a:r>
+              <a:t>IV. (percorra a tabela) "Quem ganha esses projetos são Hikvision, Dahua e Huawei. A Intelbras chega às cidades pelos integradores, um canal de no máximo 16% das vendas, com 'avanço gradual', nas palavras dela. E o detalhe: o acordo de acionistas deixa a Dahua livre para competir em projetos. Nas cidades, a fornecedora é a rival."</a:t>
+            </a:r>
+          </a:p>
+          <a:p>
+            <a:r>
+              <a:t>FECHO: "Resumo: a Intelbras é dona do mercado do instalador; no mercado que mais cresce, ela é pequena e enfrenta quem tem 20 a 50 vezes mais P&amp;D."</a:t>
             </a:r>
           </a:p>
           <a:p/>
@@ -4197,27 +3648,47 @@
           </a:p>
           <a:p>
             <a:r>
-              <a:t>• Por que o instalador escolhe Intelbras: o custo total do serviço (achar o produto, saber instalar, suporte, não voltar ao cliente). ~500 distribuidores, 68% das vendas, 95% exclusivos por opção; &gt;90 mil instaladores; 370 mil qualificações em 2025.</a:t>
-            </a:r>
-          </a:p>
-          <a:p>
-            <a:r>
-              <a:t>• Preço: a Intelbras é tomadora de preço ("o mercado define os preços", FRE 2.2). A margem de Segurança oscila 33–37% desde 2020, sem tendência de alta.</a:t>
-            </a:r>
-          </a:p>
-          <a:p>
-            <a:r>
-              <a:t>• Dahua: ~50% do custo de Segurança (média 2021–25); contrato vence em dez/2028; venda das ações autorizada desde 2023, nada vendido.</a:t>
-            </a:r>
-          </a:p>
-          <a:p>
-            <a:r>
-              <a:t>• Mercado implícito em 2025: 1,049 × 43/44 − 1 ≈ +2,5%. A Abese fala em +16%, mas inclui serviços (monitoramento, portaria).</a:t>
-            </a:r>
-          </a:p>
-          <a:p>
-            <a:r>
-              <a:t>• Mecanismo de compra: risco percebido + queda do preço por câmera + troca de mão de obra (portaria remota reduz a taxa condominial em 15–50%).</a:t>
+              <a:t>• Por que o canal não ajuda nas cidades: quem especifica é o engenheiro do integrador ou da prefeitura, por licitação. Comparam especificação técnica (IA, analíticos, integração com bases públicas) e preço, não disponibilidade no distribuidor. É o oposto do residencial e das PMEs.</a:t>
+            </a:r>
+          </a:p>
+          <a:p>
+            <a:r>
+              <a:t>• Por que o P&amp;D importa ali: reconhecimento facial e de placas, análise de vídeo com IA e softwares de comando exigem P&amp;D de núcleo (chips, algoritmos, nuvem). A Intelbras usa a tecnologia da Dahua nas câmeras e tem o software Seventh (VMS), mas não tem escala de P&amp;D própria.</a:t>
+            </a:r>
+          </a:p>
+          <a:p>
+            <a:r>
+              <a:t>• A Intelbras está nas cidades? Sim, mas pequena e sem dado de share. O FRE diz que Segurança mira "cidades inteligentes" e que os integradores atendem esses projetos. Há cases (UEL; bairro Pedra Branca, em Palhoça) e câmeras de leitura de placa em municípios menores (cercamento eletrônico).</a:t>
+            </a:r>
+          </a:p>
+          <a:p>
+            <a:r>
+              <a:t>• Geopolítica: EUA e Reino Unido restringem câmeras chinesas em órgãos públicos; no Brasil não há restrição em vigor. Como as câmeras da Intelbras são feitas pela Dahua, uma eventual restrição não necessariamente a favoreceria.</a:t>
+            </a:r>
+          </a:p>
+          <a:p>
+            <a:r>
+              <a:t>• Drivers do núcleo (instalador), que continuam valendo:</a:t>
+            </a:r>
+          </a:p>
+          <a:p>
+            <a:r>
+              <a:t>  – percepção de insegurança (17% → 38% → 30%) com crime em queda;</a:t>
+            </a:r>
+          </a:p>
+          <a:p>
+            <a:r>
+              <a:t>  – lançamentos imobiliários +30% em 2025 (instalação em 2027–28);</a:t>
+            </a:r>
+          </a:p>
+          <a:p>
+            <a:r>
+              <a:t>  – retrofit de 13,3 mi de unidades em condomínio.</a:t>
+            </a:r>
+          </a:p>
+          <a:p>
+            <a:r>
+              <a:t>• Posição no núcleo: share estável (43–44%) e margem bruta de Segurança caindo de 37,4% (2023) para 33,2% (2025); cresce com o mercado.</a:t>
             </a:r>
           </a:p>
           <a:p/>
@@ -4228,22 +3699,102 @@
           </a:p>
           <a:p>
             <a:r>
-              <a:t>I: Planilha 2T26 e DFP NE 31. ROIC = (906,7 − 19,3% × 2.730,3) ÷ 1.357,1 = 28,0%. Sem ICMS-AM (R$180,0 mi): 14,7%. Lucro bruto 906,7 ÷ 1.342,5 = 67,5%.</a:t>
-            </a:r>
-          </a:p>
-          <a:p>
-            <a:r>
-              <a:t>II: Hikvision US$12,95 bi; Dahua ≈US$4,5 bi; Intelbras R$4.460 mi ÷ 5,58 ≈ US$0,80 bi. Multilaser/HiLook em Manaus desde 2022 (Forbes). Rivais: FRE 1.4 p.26; Control iD (datasheet); Imou via AliExpress.</a:t>
-            </a:r>
-          </a:p>
-          <a:p>
-            <a:r>
-              <a:t>III: Quaest (17% out/24, 38% nov/25, 30% jun/26); Anuário FBSP (MVI −8,2% em 2025); Abrainc/Fipe (+30,1%; 85,9% MCMV jan–out); CNEFE (13,3 mi); SíndicoNet/Abese (14 mil condomínios; +24%).</a:t>
-            </a:r>
-          </a:p>
-          <a:p>
-            <a:r>
-              <a:t>IV: BTG CEO Conference 2021 (43% CFTV, 2020); Genial (54% CFTV, c.2022); FRE 2026 (43% e 44% do segmento). Margem bruta de Segurança: DFPs 2021–25.</a:t>
+              <a:t>I: Planilha 2T26; DFP NE 31; FRE 1.4 (44%; 68% distribuição). ROIC = (906,7 − 19,3% × 2.730,3) ÷ 1.357,1 = 28,0%; sem ICMS-AM 14,7%.</a:t>
+            </a:r>
+          </a:p>
+          <a:p>
+            <a:r>
+              <a:t>II:</a:t>
+            </a:r>
+          </a:p>
+          <a:p>
+            <a:r>
+              <a:t>• Hikvision: RMB 11,75 bi em P&amp;D (12,70% da receita, relatório 2025) × 0,776 ≈ R$9,1 bi.</a:t>
+            </a:r>
+          </a:p>
+          <a:p>
+            <a:r>
+              <a:t>• Dahua: RMB 4,34 bi (13,24%) ≈ R$3,4 bi.</a:t>
+            </a:r>
+          </a:p>
+          <a:p>
+            <a:r>
+              <a:t>• Intelbras: R$179,3 mi (DFP NE 13) = 4,0% da receita.</a:t>
+            </a:r>
+          </a:p>
+          <a:p>
+            <a:r>
+              <a:t>• 9,1 ÷ 0,18 ≈ 51x; 3,4 ÷ 0,18 ≈ 19x.</a:t>
+            </a:r>
+          </a:p>
+          <a:p>
+            <a:r>
+              <a:t>• Memoori: Hikvision e Dahua ≈ 1/3 da receita global; Omdia: Hikvision 25% (2023).</a:t>
+            </a:r>
+          </a:p>
+          <a:p>
+            <a:r>
+              <a:t>III:</a:t>
+            </a:r>
+          </a:p>
+          <a:p>
+            <a:r>
+              <a:t>• Statista via Plataforma CSC: investimento em cidades inteligentes no Brasil de US$1,35 bi (2025) para &gt;US$2 bi (2029), quase 12% a.a.</a:t>
+            </a:r>
+          </a:p>
+          <a:p>
+            <a:r>
+              <a:t>• MarketsandMarkets: videomonitoramento no Brasil de US$495,6 mi (2025) para US$606,3 mi (2030), 3,4% a.a.</a:t>
+            </a:r>
+          </a:p>
+          <a:p>
+            <a:r>
+              <a:t>• Fontes diferentes: comparar como ordem de grandeza.</a:t>
+            </a:r>
+          </a:p>
+          <a:p>
+            <a:r>
+              <a:t>• SSP-SP (Muralha Paulista, 94 mil câmeras, 300+ municípios); Prefeitura de SP (Smart Sampa, 40 mil câmeras em set/25: 20 mil públicas + 20 mil privadas); Diário do Rio (21/04/2025).</a:t>
+            </a:r>
+          </a:p>
+          <a:p>
+            <a:r>
+              <a:t>IV:</a:t>
+            </a:r>
+          </a:p>
+          <a:p>
+            <a:r>
+              <a:t>• Diário do Rio (acordos com Hikvision e Dahua; 21,6 mil câmeras corporais Hikvision);</a:t>
+            </a:r>
+          </a:p>
+          <a:p>
+            <a:r>
+              <a:t>• Prefeitura de SP (visita à Hikvision, 24/04/2025);</a:t>
+            </a:r>
+          </a:p>
+          <a:p>
+            <a:r>
+              <a:t>• Prefeitura de SJC (CSI com sistema Hikvision);</a:t>
+            </a:r>
+          </a:p>
+          <a:p>
+            <a:r>
+              <a:t>• Baguete (Metrô do Recife, 1.380 câmeras Dahua, R$61,5 mi; Limeira com Dahua);</a:t>
+            </a:r>
+          </a:p>
+          <a:p>
+            <a:r>
+              <a:t>• DCD (Campinas, Huawei e CPqD);</a:t>
+            </a:r>
+          </a:p>
+          <a:p>
+            <a:r>
+              <a:t>• FRE 1.4 (integradores e contas nomeadas; "avanço gradual em projetos de maior porte");</a:t>
+            </a:r>
+          </a:p>
+          <a:p>
+            <a:r>
+              <a:t>• Acordo de Acionistas, cl. 12.1.</a:t>
             </a:r>
           </a:p>
         </p:txBody>
@@ -9175,7 +8726,7 @@
           <a:lstStyle/>
           <a:p>
             <a:r>
-              <a:t>Segurança: o único negócio que cria valor</a:t>
+              <a:t>Segurança: líder no instalador, coadjuvante nas cidades</a:t>
             </a:r>
           </a:p>
         </p:txBody>
@@ -9196,7 +8747,7 @@
           <a:lstStyle/>
           <a:p>
             <a:r>
-              <a:t>Líder com 44% de share e retorno de ~28%, mas cresce com o mercado e sem poder de preço; a demanda vem da obra e do retrofit, não do medo</a:t>
+              <a:t>Domina o mercado do instalador; nas cidades inteligentes, o driver que mais cresce, enfrenta rivais com até 51x mais P&amp;D, inclusive a fornecedora</a:t>
             </a:r>
           </a:p>
         </p:txBody>
@@ -9217,7 +8768,7 @@
           <a:lstStyle/>
           <a:p>
             <a:r>
-              <a:t>I. Análise: 61% da receita, 2/3 do lucro bruto e retorno acima da Selic</a:t>
+              <a:t>I. Análise: a força está no mercado do instalador</a:t>
             </a:r>
           </a:p>
         </p:txBody>
@@ -9259,7 +8810,7 @@
           <a:lstStyle/>
           <a:p>
             <a:r>
-              <a:t>II. Concorrência: rivais 5 a 16 vezes maiores, um deles já em Manaus</a:t>
+              <a:t>II. Concorrência: os rivais investem 19 a 51 vezes mais em P&amp;D</a:t>
             </a:r>
           </a:p>
         </p:txBody>
@@ -9280,7 +8831,7 @@
           <a:lstStyle/>
           <a:p>
             <a:r>
-              <a:t>Receita total em 2025 (US$ bi) e principal rival por submercado</a:t>
+              <a:t>Gasto com P&amp;D em 2025 (R$ bi) e % da receita</a:t>
             </a:r>
           </a:p>
         </p:txBody>
@@ -9301,7 +8852,7 @@
           <a:lstStyle/>
           <a:p>
             <a:r>
-              <a:t>III. Drivers: a obra e o retrofit sustentam; o medo não acelera</a:t>
+              <a:t>III. Driver: cidades inteligentes crescem 3 vezes mais que o vídeo total</a:t>
             </a:r>
           </a:p>
         </p:txBody>
@@ -9322,7 +8873,7 @@
           <a:lstStyle/>
           <a:p>
             <a:r>
-              <a:t>Percepção de insegurança, lançamentos imobiliários e estoque de condomínios</a:t>
+              <a:t>Crescimento anual esperado no Brasil (%) e escala dos programas públicos de câmeras</a:t>
             </a:r>
           </a:p>
         </p:txBody>
@@ -9343,7 +8894,7 @@
           <a:lstStyle/>
           <a:p>
             <a:r>
-              <a:t>IV. Posição: share estável e margem em queda; cresce com o mercado</a:t>
+              <a:t>IV. Nas cidades, quem ganha são Hikvision, Dahua e Huawei</a:t>
             </a:r>
           </a:p>
         </p:txBody>
@@ -9364,7 +8915,7 @@
           <a:lstStyle/>
           <a:p>
             <a:r>
-              <a:t>Share da Intelbras em Segurança (%) e margem bruta do segmento (%)</a:t>
+              <a:t>Grandes projetos públicos de videomonitoramento no Brasil e o fornecedor citado</a:t>
             </a:r>
           </a:p>
         </p:txBody>
@@ -9385,7 +8936,7 @@
           <a:lstStyle/>
           <a:p>
             <a:r>
-              <a:t>Fontes: DFPs 2021–25 (NE 31); Planilha 2T26; FRE 2026 (1.4); Hikvision e Dahua (2025); Forbes (Multilaser); Quaest; Anuário FBSP; Abrainc/Fipe; CNEFE; Abese; BTG CEO Conference 2021; Genial. ROIC: cálculo próprio.</a:t>
+              <a:t>Fontes: DFP 2025 (NE 13, 31); FRE 2026 (1.2, 1.4); Hikvision e Dahua, relatórios 2025; Memoori; Statista (via Plataforma CSC); MarketsandMarkets; SSP-SP; Prefeitura de SP; Diário do Rio; Prefeitura de SJC; Baguete; DCD. ROIC: cálculo próprio.</a:t>
             </a:r>
           </a:p>
         </p:txBody>
@@ -9410,7 +8961,7 @@
       </p:graphicFrame>
       <p:sp>
         <p:nvSpPr>
-          <p:cNvPr id="18" name="KPI ROIC estimad"/>
+          <p:cNvPr id="18" name="KPI de share no "/>
           <p:cNvSpPr txBox="1"/>
           <p:nvPr/>
         </p:nvSpPr>
@@ -9441,7 +8992,7 @@
                   <a:srgbClr val="009F41"/>
                 </a:solidFill>
               </a:rPr>
-              <a:t>~28%</a:t>
+              <a:t>44%</a:t>
             </a:r>
           </a:p>
           <a:p>
@@ -9456,14 +9007,14 @@
                   <a:srgbClr val="595959"/>
                 </a:solidFill>
               </a:rPr>
-              <a:t>ROIC estimado (~15% sem o ICMS de Manaus)</a:t>
-            </a:r>
-          </a:p>
-        </p:txBody>
-      </p:sp>
-      <p:sp>
-        <p:nvSpPr>
-          <p:cNvPr id="19" name="KPI do lucro bru"/>
+              <a:t>de share no Brasil, estável</a:t>
+            </a:r>
+          </a:p>
+        </p:txBody>
+      </p:sp>
+      <p:sp>
+        <p:nvSpPr>
+          <p:cNvPr id="19" name="KPI ROIC estimad"/>
           <p:cNvSpPr txBox="1"/>
           <p:nvPr/>
         </p:nvSpPr>
@@ -9494,7 +9045,7 @@
                   <a:srgbClr val="1A1A1A"/>
                 </a:solidFill>
               </a:rPr>
-              <a:t>67,5%</a:t>
+              <a:t>~28%</a:t>
             </a:r>
           </a:p>
           <a:p>
@@ -9509,14 +9060,14 @@
                   <a:srgbClr val="595959"/>
                 </a:solidFill>
               </a:rPr>
-              <a:t>do lucro bruto da Intelbras</a:t>
-            </a:r>
-          </a:p>
-        </p:txBody>
-      </p:sp>
-      <p:sp>
-        <p:nvSpPr>
-          <p:cNvPr id="20" name="KPI de crescimen"/>
+              <a:t>ROIC estimado (~15% sem o ICMS de Manaus)</a:t>
+            </a:r>
+          </a:p>
+        </p:txBody>
+      </p:sp>
+      <p:sp>
+        <p:nvSpPr>
+          <p:cNvPr id="20" name="KPI das vendas v"/>
           <p:cNvSpPr txBox="1"/>
           <p:nvPr/>
         </p:nvSpPr>
@@ -9547,7 +9098,7 @@
                   <a:srgbClr val="1A1A1A"/>
                 </a:solidFill>
               </a:rPr>
-              <a:t>+18% a.a.</a:t>
+              <a:t>68%</a:t>
             </a:r>
           </a:p>
           <a:p>
@@ -9562,22 +9113,22 @@
                   <a:srgbClr val="595959"/>
                 </a:solidFill>
               </a:rPr>
-              <a:t>de crescimento em 2019–25</a:t>
+              <a:t>das vendas via distribuidor e instalador</a:t>
             </a:r>
           </a:p>
         </p:txBody>
       </p:sp>
       <p:graphicFrame>
         <p:nvGraphicFramePr>
-          <p:cNvPr id="21" name="Grafico escala Seguranca"/>
+          <p:cNvPr id="21" name="Grafico P&amp;D"/>
           <p:cNvGraphicFramePr>
             <a:graphicFrameLocks noGrp="1"/>
           </p:cNvGraphicFramePr>
           <p:nvPr/>
         </p:nvGraphicFramePr>
         <p:xfrm>
-          <a:off x="6428232" y="1591056"/>
-          <a:ext cx="2240280" cy="1828800"/>
+          <a:off x="6428232" y="1563624"/>
+          <a:ext cx="3840480" cy="1920240"/>
         </p:xfrm>
         <a:graphic>
           <a:graphicData uri="http://schemas.openxmlformats.org/drawingml/2006/chart">
@@ -9587,14 +9138,297 @@
       </p:graphicFrame>
       <p:sp>
         <p:nvSpPr>
-          <p:cNvPr id="22" name="Rivais Seguranca faixa 0"/>
+          <p:cNvPr id="22" name="Destaque 51x"/>
+          <p:cNvSpPr txBox="1"/>
+          <p:nvPr/>
+        </p:nvSpPr>
+        <p:spPr>
+          <a:xfrm>
+            <a:off x="10360152" y="1591056"/>
+            <a:ext cx="1600200" cy="914400"/>
+          </a:xfrm>
+          <a:prstGeom prst="rect">
+            <a:avLst/>
+          </a:prstGeom>
+          <a:noFill/>
+        </p:spPr>
+        <p:txBody>
+          <a:bodyPr wrap="square" lIns="0" rIns="0" tIns="0" bIns="0" anchor="t">
+            <a:spAutoFit/>
+          </a:bodyPr>
+          <a:lstStyle/>
+          <a:p>
+            <a:pPr algn="l">
+              <a:spcAft>
+                <a:spcPts val="0"/>
+              </a:spcAft>
+            </a:pPr>
+            <a:r>
+              <a:rPr sz="2200" b="1" i="0">
+                <a:solidFill>
+                  <a:srgbClr val="1A1A1A"/>
+                </a:solidFill>
+              </a:rPr>
+              <a:t>51x</a:t>
+            </a:r>
+          </a:p>
+          <a:p>
+            <a:pPr algn="l">
+              <a:spcAft>
+                <a:spcPts val="0"/>
+              </a:spcAft>
+            </a:pPr>
+            <a:r>
+              <a:rPr sz="900" b="0" i="0">
+                <a:solidFill>
+                  <a:srgbClr val="595959"/>
+                </a:solidFill>
+              </a:rPr>
+              <a:t>o P&amp;D da Hikvision</a:t>
+            </a:r>
+          </a:p>
+        </p:txBody>
+      </p:sp>
+      <p:sp>
+        <p:nvSpPr>
+          <p:cNvPr id="23" name="Destaque um terco"/>
+          <p:cNvSpPr txBox="1"/>
+          <p:nvPr/>
+        </p:nvSpPr>
+        <p:spPr>
+          <a:xfrm>
+            <a:off x="10360152" y="2276856"/>
+            <a:ext cx="1600200" cy="914400"/>
+          </a:xfrm>
+          <a:prstGeom prst="rect">
+            <a:avLst/>
+          </a:prstGeom>
+          <a:noFill/>
+        </p:spPr>
+        <p:txBody>
+          <a:bodyPr wrap="square" lIns="0" rIns="0" tIns="0" bIns="0" anchor="t">
+            <a:spAutoFit/>
+          </a:bodyPr>
+          <a:lstStyle/>
+          <a:p>
+            <a:pPr algn="l">
+              <a:spcAft>
+                <a:spcPts val="0"/>
+              </a:spcAft>
+            </a:pPr>
+            <a:r>
+              <a:rPr sz="2200" b="1" i="0">
+                <a:solidFill>
+                  <a:srgbClr val="1A1A1A"/>
+                </a:solidFill>
+              </a:rPr>
+              <a:t>≈1/3</a:t>
+            </a:r>
+          </a:p>
+          <a:p>
+            <a:pPr algn="l">
+              <a:spcAft>
+                <a:spcPts val="0"/>
+              </a:spcAft>
+            </a:pPr>
+            <a:r>
+              <a:rPr sz="900" b="0" i="0">
+                <a:solidFill>
+                  <a:srgbClr val="595959"/>
+                </a:solidFill>
+              </a:rPr>
+              <a:t>do mercado mundial de vídeo é de Hikvision + Dahua</a:t>
+            </a:r>
+          </a:p>
+        </p:txBody>
+      </p:sp>
+      <p:graphicFrame>
+        <p:nvGraphicFramePr>
+          <p:cNvPr id="24" name="Grafico crescimento cidades"/>
+          <p:cNvGraphicFramePr>
+            <a:graphicFrameLocks noGrp="1"/>
+          </p:cNvGraphicFramePr>
+          <p:nvPr/>
+        </p:nvGraphicFramePr>
+        <p:xfrm>
+          <a:off x="566928" y="4425696"/>
+          <a:ext cx="3246120" cy="1920240"/>
+        </p:xfrm>
+        <a:graphic>
+          <a:graphicData uri="http://schemas.openxmlformats.org/drawingml/2006/chart">
+            <c:chart xmlns:c="http://schemas.openxmlformats.org/drawingml/2006/chart" r:id="rId4"/>
+          </a:graphicData>
+        </a:graphic>
+      </p:graphicFrame>
+      <p:sp>
+        <p:nvSpPr>
+          <p:cNvPr id="25" name="Destaque Muralha"/>
+          <p:cNvSpPr txBox="1"/>
+          <p:nvPr/>
+        </p:nvSpPr>
+        <p:spPr>
+          <a:xfrm>
+            <a:off x="3950208" y="4407408"/>
+            <a:ext cx="2148840" cy="914400"/>
+          </a:xfrm>
+          <a:prstGeom prst="rect">
+            <a:avLst/>
+          </a:prstGeom>
+          <a:noFill/>
+        </p:spPr>
+        <p:txBody>
+          <a:bodyPr wrap="square" lIns="0" rIns="0" tIns="0" bIns="0" anchor="t">
+            <a:spAutoFit/>
+          </a:bodyPr>
+          <a:lstStyle/>
+          <a:p>
+            <a:pPr algn="l">
+              <a:spcAft>
+                <a:spcPts val="0"/>
+              </a:spcAft>
+            </a:pPr>
+            <a:r>
+              <a:rPr sz="2000" b="1" i="0">
+                <a:solidFill>
+                  <a:srgbClr val="1A1A1A"/>
+                </a:solidFill>
+              </a:rPr>
+              <a:t>94 mil</a:t>
+            </a:r>
+          </a:p>
+          <a:p>
+            <a:pPr algn="l">
+              <a:spcAft>
+                <a:spcPts val="0"/>
+              </a:spcAft>
+            </a:pPr>
+            <a:r>
+              <a:rPr sz="900" b="0" i="0">
+                <a:solidFill>
+                  <a:srgbClr val="595959"/>
+                </a:solidFill>
+              </a:rPr>
+              <a:t>câmeras no Muralha Paulista, em 300+ municípios</a:t>
+            </a:r>
+          </a:p>
+        </p:txBody>
+      </p:sp>
+      <p:sp>
+        <p:nvSpPr>
+          <p:cNvPr id="26" name="Destaque Smart Sampa"/>
+          <p:cNvSpPr txBox="1"/>
+          <p:nvPr/>
+        </p:nvSpPr>
+        <p:spPr>
+          <a:xfrm>
+            <a:off x="3950208" y="5065776"/>
+            <a:ext cx="2148840" cy="914400"/>
+          </a:xfrm>
+          <a:prstGeom prst="rect">
+            <a:avLst/>
+          </a:prstGeom>
+          <a:noFill/>
+        </p:spPr>
+        <p:txBody>
+          <a:bodyPr wrap="square" lIns="0" rIns="0" tIns="0" bIns="0" anchor="t">
+            <a:spAutoFit/>
+          </a:bodyPr>
+          <a:lstStyle/>
+          <a:p>
+            <a:pPr algn="l">
+              <a:spcAft>
+                <a:spcPts val="0"/>
+              </a:spcAft>
+            </a:pPr>
+            <a:r>
+              <a:rPr sz="2000" b="1" i="0">
+                <a:solidFill>
+                  <a:srgbClr val="1A1A1A"/>
+                </a:solidFill>
+              </a:rPr>
+              <a:t>40 mil</a:t>
+            </a:r>
+          </a:p>
+          <a:p>
+            <a:pPr algn="l">
+              <a:spcAft>
+                <a:spcPts val="0"/>
+              </a:spcAft>
+            </a:pPr>
+            <a:r>
+              <a:rPr sz="900" b="0" i="0">
+                <a:solidFill>
+                  <a:srgbClr val="595959"/>
+                </a:solidFill>
+              </a:rPr>
+              <a:t>câmeras no Smart Sampa (SP)</a:t>
+            </a:r>
+          </a:p>
+        </p:txBody>
+      </p:sp>
+      <p:sp>
+        <p:nvSpPr>
+          <p:cNvPr id="27" name="Destaque Rio"/>
+          <p:cNvSpPr txBox="1"/>
+          <p:nvPr/>
+        </p:nvSpPr>
+        <p:spPr>
+          <a:xfrm>
+            <a:off x="3950208" y="5724144"/>
+            <a:ext cx="2148840" cy="914400"/>
+          </a:xfrm>
+          <a:prstGeom prst="rect">
+            <a:avLst/>
+          </a:prstGeom>
+          <a:noFill/>
+        </p:spPr>
+        <p:txBody>
+          <a:bodyPr wrap="square" lIns="0" rIns="0" tIns="0" bIns="0" anchor="t">
+            <a:spAutoFit/>
+          </a:bodyPr>
+          <a:lstStyle/>
+          <a:p>
+            <a:pPr algn="l">
+              <a:spcAft>
+                <a:spcPts val="0"/>
+              </a:spcAft>
+            </a:pPr>
+            <a:r>
+              <a:rPr sz="2000" b="1" i="0">
+                <a:solidFill>
+                  <a:srgbClr val="1A1A1A"/>
+                </a:solidFill>
+              </a:rPr>
+              <a:t>92</a:t>
+            </a:r>
+          </a:p>
+          <a:p>
+            <a:pPr algn="l">
+              <a:spcAft>
+                <a:spcPts val="0"/>
+              </a:spcAft>
+            </a:pPr>
+            <a:r>
+              <a:rPr sz="900" b="0" i="0">
+                <a:solidFill>
+                  <a:srgbClr val="595959"/>
+                </a:solidFill>
+              </a:rPr>
+              <a:t>municípios no plano do Rio com Hikvision e Dahua</a:t>
+            </a:r>
+          </a:p>
+        </p:txBody>
+      </p:sp>
+      <p:sp>
+        <p:nvSpPr>
+          <p:cNvPr id="28" name="Projetos faixa 0"/>
           <p:cNvSpPr/>
           <p:nvPr/>
         </p:nvSpPr>
         <p:spPr>
           <a:xfrm>
-            <a:off x="8759952" y="1563624"/>
-            <a:ext cx="3200400" cy="356616"/>
+            <a:off x="6428232" y="4425696"/>
+            <a:ext cx="5532120" cy="256032"/>
           </a:xfrm>
           <a:prstGeom prst="rect">
             <a:avLst/>
@@ -9631,14 +9465,14 @@
       </p:sp>
       <p:sp>
         <p:nvSpPr>
-          <p:cNvPr id="23" name="Rivais Seguranca sub 0"/>
+          <p:cNvPr id="29" name="Projeto 0"/>
           <p:cNvSpPr txBox="1"/>
           <p:nvPr/>
         </p:nvSpPr>
         <p:spPr>
           <a:xfrm>
-            <a:off x="8805672" y="1563624"/>
-            <a:ext cx="1234439" cy="356616"/>
+            <a:off x="6473952" y="4425696"/>
+            <a:ext cx="1828800" cy="256032"/>
           </a:xfrm>
           <a:prstGeom prst="rect">
             <a:avLst/>
@@ -9657,26 +9491,26 @@
               </a:spcAft>
             </a:pPr>
             <a:r>
-              <a:rPr sz="850" b="1" i="0">
+              <a:rPr sz="900" b="1" i="0">
                 <a:solidFill>
                   <a:srgbClr val="1A1A1A"/>
                 </a:solidFill>
               </a:rPr>
-              <a:t>CFTV profissional</a:t>
-            </a:r>
-          </a:p>
-        </p:txBody>
-      </p:sp>
-      <p:sp>
-        <p:nvSpPr>
-          <p:cNvPr id="24" name="Rivais Seguranca rivais 0"/>
+              <a:t>Rio de Janeiro (estado)</a:t>
+            </a:r>
+          </a:p>
+        </p:txBody>
+      </p:sp>
+      <p:sp>
+        <p:nvSpPr>
+          <p:cNvPr id="30" name="Projeto det 0"/>
           <p:cNvSpPr txBox="1"/>
           <p:nvPr/>
         </p:nvSpPr>
         <p:spPr>
           <a:xfrm>
-            <a:off x="10040112" y="1563624"/>
-            <a:ext cx="1920240" cy="356616"/>
+            <a:off x="8302752" y="4425696"/>
+            <a:ext cx="2331720" cy="256032"/>
           </a:xfrm>
           <a:prstGeom prst="rect">
             <a:avLst/>
@@ -9695,108 +9529,34 @@
               </a:spcAft>
             </a:pPr>
             <a:r>
-              <a:rPr sz="800" b="0" i="0">
+              <a:rPr sz="850" b="0" i="0">
                 <a:solidFill>
                   <a:srgbClr val="595959"/>
                 </a:solidFill>
               </a:rPr>
-              <a:t>Hikvision, montada em Manaus pela Multilaser</a:t>
-            </a:r>
-          </a:p>
-        </p:txBody>
-      </p:sp>
-      <p:sp>
-        <p:nvSpPr>
-          <p:cNvPr id="25" name="Rivais Seguranca sub 1"/>
-          <p:cNvSpPr txBox="1"/>
-          <p:nvPr/>
-        </p:nvSpPr>
-        <p:spPr>
-          <a:xfrm>
-            <a:off x="8805672" y="1947672"/>
-            <a:ext cx="1234439" cy="356616"/>
-          </a:xfrm>
-          <a:prstGeom prst="rect">
-            <a:avLst/>
-          </a:prstGeom>
-          <a:noFill/>
-        </p:spPr>
-        <p:txBody>
-          <a:bodyPr wrap="square" lIns="0" rIns="0" tIns="0" bIns="0" anchor="ctr">
-            <a:spAutoFit/>
-          </a:bodyPr>
-          <a:lstStyle/>
-          <a:p>
-            <a:pPr algn="l">
-              <a:spcAft>
-                <a:spcPts val="0"/>
-              </a:spcAft>
-            </a:pPr>
-            <a:r>
-              <a:rPr sz="850" b="1" i="0">
-                <a:solidFill>
-                  <a:srgbClr val="1A1A1A"/>
-                </a:solidFill>
-              </a:rPr>
-              <a:t>Controle de acesso</a:t>
-            </a:r>
-          </a:p>
-        </p:txBody>
-      </p:sp>
-      <p:sp>
-        <p:nvSpPr>
-          <p:cNvPr id="26" name="Rivais Seguranca rivais 1"/>
-          <p:cNvSpPr txBox="1"/>
-          <p:nvPr/>
-        </p:nvSpPr>
-        <p:spPr>
-          <a:xfrm>
-            <a:off x="10040112" y="1947672"/>
-            <a:ext cx="1920240" cy="356616"/>
-          </a:xfrm>
-          <a:prstGeom prst="rect">
-            <a:avLst/>
-          </a:prstGeom>
-          <a:noFill/>
-        </p:spPr>
-        <p:txBody>
-          <a:bodyPr wrap="square" lIns="0" rIns="0" tIns="0" bIns="0" anchor="ctr">
-            <a:spAutoFit/>
-          </a:bodyPr>
-          <a:lstStyle/>
-          <a:p>
-            <a:pPr algn="l">
-              <a:spcAft>
-                <a:spcPts val="0"/>
-              </a:spcAft>
-            </a:pPr>
-            <a:r>
-              <a:rPr sz="800" b="0" i="0">
-                <a:solidFill>
-                  <a:srgbClr val="595959"/>
-                </a:solidFill>
-              </a:rPr>
-              <a:t>Control iD (BR), Hikvision</a:t>
-            </a:r>
-          </a:p>
-        </p:txBody>
-      </p:sp>
-      <p:sp>
-        <p:nvSpPr>
-          <p:cNvPr id="27" name="Rivais Seguranca faixa 2"/>
+              <a:t>acordo de 2025 para 92 municípios</a:t>
+            </a:r>
+          </a:p>
+        </p:txBody>
+      </p:sp>
+      <p:sp>
+        <p:nvSpPr>
+          <p:cNvPr id="31" name="Projeto selo 0"/>
           <p:cNvSpPr/>
           <p:nvPr/>
         </p:nvSpPr>
         <p:spPr>
           <a:xfrm>
-            <a:off x="8759952" y="2331720"/>
-            <a:ext cx="3200400" cy="356616"/>
-          </a:xfrm>
-          <a:prstGeom prst="rect">
-            <a:avLst/>
+            <a:off x="10680192" y="4453128"/>
+            <a:ext cx="1261872" cy="201168"/>
+          </a:xfrm>
+          <a:prstGeom prst="roundRect">
+            <a:avLst>
+              <a:gd name="adj" fmla="val 15000"/>
+            </a:avLst>
           </a:prstGeom>
           <a:solidFill>
-            <a:srgbClr val="F2F2F2"/>
+            <a:srgbClr val="1A1A1A"/>
           </a:solidFill>
           <a:ln>
             <a:noFill/>
@@ -9822,19 +9582,27 @@
           <a:lstStyle/>
           <a:p>
             <a:pPr algn="ctr"/>
-          </a:p>
-        </p:txBody>
-      </p:sp>
-      <p:sp>
-        <p:nvSpPr>
-          <p:cNvPr id="28" name="Rivais Seguranca sub 2"/>
+            <a:r>
+              <a:rPr sz="850" b="1">
+                <a:solidFill>
+                  <a:srgbClr val="FFFFFF"/>
+                </a:solidFill>
+              </a:rPr>
+              <a:t>Hikvision e Dahua</a:t>
+            </a:r>
+          </a:p>
+        </p:txBody>
+      </p:sp>
+      <p:sp>
+        <p:nvSpPr>
+          <p:cNvPr id="32" name="Projeto 1"/>
           <p:cNvSpPr txBox="1"/>
           <p:nvPr/>
         </p:nvSpPr>
         <p:spPr>
           <a:xfrm>
-            <a:off x="8805672" y="2331720"/>
-            <a:ext cx="1234439" cy="356616"/>
+            <a:off x="6473952" y="4700016"/>
+            <a:ext cx="1828800" cy="256032"/>
           </a:xfrm>
           <a:prstGeom prst="rect">
             <a:avLst/>
@@ -9853,26 +9621,26 @@
               </a:spcAft>
             </a:pPr>
             <a:r>
-              <a:rPr sz="850" b="1" i="0">
+              <a:rPr sz="900" b="1" i="0">
                 <a:solidFill>
                   <a:srgbClr val="1A1A1A"/>
                 </a:solidFill>
               </a:rPr>
-              <a:t>Alarmes</a:t>
-            </a:r>
-          </a:p>
-        </p:txBody>
-      </p:sp>
-      <p:sp>
-        <p:nvSpPr>
-          <p:cNvPr id="29" name="Rivais Seguranca rivais 2"/>
+              <a:t>São Paulo (Smart Sampa)</a:t>
+            </a:r>
+          </a:p>
+        </p:txBody>
+      </p:sp>
+      <p:sp>
+        <p:nvSpPr>
+          <p:cNvPr id="33" name="Projeto det 1"/>
           <p:cNvSpPr txBox="1"/>
           <p:nvPr/>
         </p:nvSpPr>
         <p:spPr>
           <a:xfrm>
-            <a:off x="10040112" y="2331720"/>
-            <a:ext cx="1920240" cy="356616"/>
+            <a:off x="8302752" y="4700016"/>
+            <a:ext cx="2331720" cy="256032"/>
           </a:xfrm>
           <a:prstGeom prst="rect">
             <a:avLst/>
@@ -9891,108 +9659,34 @@
               </a:spcAft>
             </a:pPr>
             <a:r>
-              <a:rPr sz="800" b="0" i="0">
+              <a:rPr sz="850" b="0" i="0">
                 <a:solidFill>
                   <a:srgbClr val="595959"/>
                 </a:solidFill>
               </a:rPr>
-              <a:t>JFL (BR)</a:t>
-            </a:r>
-          </a:p>
-        </p:txBody>
-      </p:sp>
-      <p:sp>
-        <p:nvSpPr>
-          <p:cNvPr id="30" name="Rivais Seguranca sub 3"/>
-          <p:cNvSpPr txBox="1"/>
-          <p:nvPr/>
-        </p:nvSpPr>
-        <p:spPr>
-          <a:xfrm>
-            <a:off x="8805672" y="2715768"/>
-            <a:ext cx="1234439" cy="356616"/>
-          </a:xfrm>
-          <a:prstGeom prst="rect">
-            <a:avLst/>
-          </a:prstGeom>
-          <a:noFill/>
-        </p:spPr>
-        <p:txBody>
-          <a:bodyPr wrap="square" lIns="0" rIns="0" tIns="0" bIns="0" anchor="ctr">
-            <a:spAutoFit/>
-          </a:bodyPr>
-          <a:lstStyle/>
-          <a:p>
-            <a:pPr algn="l">
-              <a:spcAft>
-                <a:spcPts val="0"/>
-              </a:spcAft>
-            </a:pPr>
-            <a:r>
-              <a:rPr sz="850" b="1" i="0">
-                <a:solidFill>
-                  <a:srgbClr val="1A1A1A"/>
-                </a:solidFill>
-              </a:rPr>
-              <a:t>Portões e interfonia</a:t>
-            </a:r>
-          </a:p>
-        </p:txBody>
-      </p:sp>
-      <p:sp>
-        <p:nvSpPr>
-          <p:cNvPr id="31" name="Rivais Seguranca rivais 3"/>
-          <p:cNvSpPr txBox="1"/>
-          <p:nvPr/>
-        </p:nvSpPr>
-        <p:spPr>
-          <a:xfrm>
-            <a:off x="10040112" y="2715768"/>
-            <a:ext cx="1920240" cy="356616"/>
-          </a:xfrm>
-          <a:prstGeom prst="rect">
-            <a:avLst/>
-          </a:prstGeom>
-          <a:noFill/>
-        </p:spPr>
-        <p:txBody>
-          <a:bodyPr wrap="square" lIns="0" rIns="0" tIns="0" bIns="0" anchor="ctr">
-            <a:spAutoFit/>
-          </a:bodyPr>
-          <a:lstStyle/>
-          <a:p>
-            <a:pPr algn="l">
-              <a:spcAft>
-                <a:spcPts val="0"/>
-              </a:spcAft>
-            </a:pPr>
-            <a:r>
-              <a:rPr sz="800" b="0" i="0">
-                <a:solidFill>
-                  <a:srgbClr val="595959"/>
-                </a:solidFill>
-              </a:rPr>
-              <a:t>PPA, Garen (BR)</a:t>
-            </a:r>
-          </a:p>
-        </p:txBody>
-      </p:sp>
-      <p:sp>
-        <p:nvSpPr>
-          <p:cNvPr id="32" name="Rivais Seguranca faixa 4"/>
+              <a:t>prefeito foi à Hikvision para ampliar (abr/25)</a:t>
+            </a:r>
+          </a:p>
+        </p:txBody>
+      </p:sp>
+      <p:sp>
+        <p:nvSpPr>
+          <p:cNvPr id="34" name="Projeto selo 1"/>
           <p:cNvSpPr/>
           <p:nvPr/>
         </p:nvSpPr>
         <p:spPr>
           <a:xfrm>
-            <a:off x="8759952" y="3099815"/>
-            <a:ext cx="3200400" cy="356616"/>
-          </a:xfrm>
-          <a:prstGeom prst="rect">
-            <a:avLst/>
+            <a:off x="10680192" y="4727448"/>
+            <a:ext cx="1261872" cy="201168"/>
+          </a:xfrm>
+          <a:prstGeom prst="roundRect">
+            <a:avLst>
+              <a:gd name="adj" fmla="val 15000"/>
+            </a:avLst>
           </a:prstGeom>
           <a:solidFill>
-            <a:srgbClr val="F2F2F2"/>
+            <a:srgbClr val="1A1A1A"/>
           </a:solidFill>
           <a:ln>
             <a:noFill/>
@@ -10018,195 +9712,33 @@
           <a:lstStyle/>
           <a:p>
             <a:pPr algn="ctr"/>
-          </a:p>
-        </p:txBody>
-      </p:sp>
-      <p:sp>
-        <p:nvSpPr>
-          <p:cNvPr id="33" name="Rivais Seguranca sub 4"/>
-          <p:cNvSpPr txBox="1"/>
-          <p:nvPr/>
-        </p:nvSpPr>
-        <p:spPr>
-          <a:xfrm>
-            <a:off x="8805672" y="3099815"/>
-            <a:ext cx="1234439" cy="356616"/>
-          </a:xfrm>
-          <a:prstGeom prst="rect">
-            <a:avLst/>
-          </a:prstGeom>
-          <a:noFill/>
-        </p:spPr>
-        <p:txBody>
-          <a:bodyPr wrap="square" lIns="0" rIns="0" tIns="0" bIns="0" anchor="ctr">
-            <a:spAutoFit/>
-          </a:bodyPr>
-          <a:lstStyle/>
-          <a:p>
-            <a:pPr algn="l">
-              <a:spcAft>
-                <a:spcPts val="0"/>
-              </a:spcAft>
-            </a:pPr>
-            <a:r>
-              <a:rPr sz="850" b="1" i="0">
-                <a:solidFill>
-                  <a:srgbClr val="1A1A1A"/>
+            <a:r>
+              <a:rPr sz="850" b="1">
+                <a:solidFill>
+                  <a:srgbClr val="FFFFFF"/>
                 </a:solidFill>
               </a:rPr>
-              <a:t>Câmeras Wi-Fi (varejo)</a:t>
-            </a:r>
-          </a:p>
-        </p:txBody>
-      </p:sp>
-      <p:sp>
-        <p:nvSpPr>
-          <p:cNvPr id="34" name="Rivais Seguranca rivais 4"/>
-          <p:cNvSpPr txBox="1"/>
-          <p:nvPr/>
-        </p:nvSpPr>
-        <p:spPr>
-          <a:xfrm>
-            <a:off x="10040112" y="3099815"/>
-            <a:ext cx="1920240" cy="356616"/>
-          </a:xfrm>
-          <a:prstGeom prst="rect">
-            <a:avLst/>
-          </a:prstGeom>
-          <a:noFill/>
-        </p:spPr>
-        <p:txBody>
-          <a:bodyPr wrap="square" lIns="0" rIns="0" tIns="0" bIns="0" anchor="ctr">
-            <a:spAutoFit/>
-          </a:bodyPr>
-          <a:lstStyle/>
-          <a:p>
-            <a:pPr algn="l">
-              <a:spcAft>
-                <a:spcPts val="0"/>
-              </a:spcAft>
-            </a:pPr>
-            <a:r>
-              <a:rPr sz="800" b="0" i="0">
-                <a:solidFill>
-                  <a:srgbClr val="595959"/>
-                </a:solidFill>
-              </a:rPr>
-              <a:t>TP-Link, Xiaomi, Imou (Dahua) via cross-border</a:t>
-            </a:r>
-          </a:p>
-        </p:txBody>
-      </p:sp>
-      <p:graphicFrame>
-        <p:nvGraphicFramePr>
-          <p:cNvPr id="35" name="Grafico percepcao"/>
-          <p:cNvGraphicFramePr>
-            <a:graphicFrameLocks noGrp="1"/>
-          </p:cNvGraphicFramePr>
-          <p:nvPr/>
-        </p:nvGraphicFramePr>
-        <p:xfrm>
-          <a:off x="566928" y="4407408"/>
-          <a:ext cx="2286000" cy="1709928"/>
-        </p:xfrm>
-        <a:graphic>
-          <a:graphicData uri="http://schemas.openxmlformats.org/drawingml/2006/chart">
-            <c:chart xmlns:c="http://schemas.openxmlformats.org/drawingml/2006/chart" r:id="rId4"/>
-          </a:graphicData>
-        </a:graphic>
-      </p:graphicFrame>
-      <p:sp>
-        <p:nvSpPr>
-          <p:cNvPr id="36" name="Rotulo percepcao"/>
-          <p:cNvSpPr txBox="1"/>
-          <p:nvPr/>
-        </p:nvSpPr>
-        <p:spPr>
-          <a:xfrm>
-            <a:off x="566928" y="4389120"/>
-            <a:ext cx="2286000" cy="182880"/>
-          </a:xfrm>
-          <a:prstGeom prst="rect">
-            <a:avLst/>
-          </a:prstGeom>
-          <a:noFill/>
-        </p:spPr>
-        <p:txBody>
-          <a:bodyPr wrap="square" lIns="0" rIns="0" tIns="0" bIns="0" anchor="t">
-            <a:spAutoFit/>
-          </a:bodyPr>
-          <a:lstStyle/>
-          <a:p>
-            <a:pPr algn="ctr">
-              <a:spcAft>
-                <a:spcPts val="0"/>
-              </a:spcAft>
-            </a:pPr>
-            <a:r>
-              <a:rPr sz="850" b="0" i="1">
-                <a:solidFill>
-                  <a:srgbClr val="595959"/>
-                </a:solidFill>
-              </a:rPr>
-              <a:t>segurança é o maior problema (%)</a:t>
-            </a:r>
-          </a:p>
-        </p:txBody>
-      </p:sp>
-      <p:sp>
-        <p:nvSpPr>
-          <p:cNvPr id="37" name="Nota MVI"/>
-          <p:cNvSpPr txBox="1"/>
-          <p:nvPr/>
-        </p:nvSpPr>
-        <p:spPr>
-          <a:xfrm>
-            <a:off x="566928" y="6172200"/>
-            <a:ext cx="2286000" cy="182880"/>
-          </a:xfrm>
-          <a:prstGeom prst="rect">
-            <a:avLst/>
-          </a:prstGeom>
-          <a:noFill/>
-        </p:spPr>
-        <p:txBody>
-          <a:bodyPr wrap="square" lIns="0" rIns="0" tIns="0" bIns="0" anchor="t">
-            <a:spAutoFit/>
-          </a:bodyPr>
-          <a:lstStyle/>
-          <a:p>
-            <a:pPr algn="ctr">
-              <a:spcAft>
-                <a:spcPts val="0"/>
-              </a:spcAft>
-            </a:pPr>
-            <a:r>
-              <a:rPr sz="800" b="0" i="1">
-                <a:solidFill>
-                  <a:srgbClr val="6B6B6B"/>
-                </a:solidFill>
-              </a:rPr>
-              <a:t>enquanto as mortes violentas caíram 8% em 2025</a:t>
-            </a:r>
-          </a:p>
-        </p:txBody>
-      </p:sp>
-      <p:sp>
-        <p:nvSpPr>
-          <p:cNvPr id="38" name="Driver lancamentos"/>
+              <a:t>Hikvision</a:t>
+            </a:r>
+          </a:p>
+        </p:txBody>
+      </p:sp>
+      <p:sp>
+        <p:nvSpPr>
+          <p:cNvPr id="35" name="Projetos faixa 2"/>
           <p:cNvSpPr/>
           <p:nvPr/>
         </p:nvSpPr>
         <p:spPr>
           <a:xfrm>
-            <a:off x="3035808" y="4453128"/>
-            <a:ext cx="1371600" cy="777240"/>
+            <a:off x="6428232" y="4974336"/>
+            <a:ext cx="5532120" cy="256032"/>
           </a:xfrm>
           <a:prstGeom prst="rect">
             <a:avLst/>
           </a:prstGeom>
           <a:solidFill>
-            <a:srgbClr val="1A1A1A"/>
+            <a:srgbClr val="F2F2F2"/>
           </a:solidFill>
           <a:ln>
             <a:noFill/>
@@ -10232,80 +9764,103 @@
           <a:lstStyle/>
           <a:p>
             <a:pPr algn="ctr"/>
-            <a:r>
-              <a:rPr sz="1800" b="1">
-                <a:solidFill>
-                  <a:srgbClr val="FFFFFF"/>
+          </a:p>
+        </p:txBody>
+      </p:sp>
+      <p:sp>
+        <p:nvSpPr>
+          <p:cNvPr id="36" name="Projeto 2"/>
+          <p:cNvSpPr txBox="1"/>
+          <p:nvPr/>
+        </p:nvSpPr>
+        <p:spPr>
+          <a:xfrm>
+            <a:off x="6473952" y="4974336"/>
+            <a:ext cx="1828800" cy="256032"/>
+          </a:xfrm>
+          <a:prstGeom prst="rect">
+            <a:avLst/>
+          </a:prstGeom>
+          <a:noFill/>
+        </p:spPr>
+        <p:txBody>
+          <a:bodyPr wrap="square" lIns="0" rIns="0" tIns="0" bIns="0" anchor="ctr">
+            <a:spAutoFit/>
+          </a:bodyPr>
+          <a:lstStyle/>
+          <a:p>
+            <a:pPr algn="l">
+              <a:spcAft>
+                <a:spcPts val="0"/>
+              </a:spcAft>
+            </a:pPr>
+            <a:r>
+              <a:rPr sz="900" b="1" i="0">
+                <a:solidFill>
+                  <a:srgbClr val="1A1A1A"/>
                 </a:solidFill>
               </a:rPr>
-              <a:t>+30%</a:t>
-            </a:r>
-          </a:p>
-          <a:p>
-            <a:pPr algn="ctr"/>
-            <a:r>
-              <a:rPr sz="900" b="0">
-                <a:solidFill>
-                  <a:srgbClr val="FFFFFF"/>
+              <a:t>São José dos Campos (CSI)</a:t>
+            </a:r>
+          </a:p>
+        </p:txBody>
+      </p:sp>
+      <p:sp>
+        <p:nvSpPr>
+          <p:cNvPr id="37" name="Projeto det 2"/>
+          <p:cNvSpPr txBox="1"/>
+          <p:nvPr/>
+        </p:nvSpPr>
+        <p:spPr>
+          <a:xfrm>
+            <a:off x="8302752" y="4974336"/>
+            <a:ext cx="2331720" cy="256032"/>
+          </a:xfrm>
+          <a:prstGeom prst="rect">
+            <a:avLst/>
+          </a:prstGeom>
+          <a:noFill/>
+        </p:spPr>
+        <p:txBody>
+          <a:bodyPr wrap="square" lIns="0" rIns="0" tIns="0" bIns="0" anchor="ctr">
+            <a:spAutoFit/>
+          </a:bodyPr>
+          <a:lstStyle/>
+          <a:p>
+            <a:pPr algn="l">
+              <a:spcAft>
+                <a:spcPts val="0"/>
+              </a:spcAft>
+            </a:pPr>
+            <a:r>
+              <a:rPr sz="850" b="0" i="0">
+                <a:solidFill>
+                  <a:srgbClr val="595959"/>
                 </a:solidFill>
               </a:rPr>
-              <a:t>lançamentos em 2025</a:t>
-            </a:r>
-          </a:p>
-        </p:txBody>
-      </p:sp>
-      <p:cxnSp>
-        <p:nvCxnSpPr>
-          <p:cNvPr id="39" name="Connector 38"/>
-          <p:cNvCxnSpPr/>
-          <p:nvPr/>
-        </p:nvCxnSpPr>
-        <p:spPr>
-          <a:xfrm>
-            <a:off x="4434840" y="4837176"/>
-            <a:ext cx="246888" cy="0"/>
-          </a:xfrm>
-          <a:prstGeom prst="line">
-            <a:avLst/>
-          </a:prstGeom>
-          <a:ln w="22225">
-            <a:solidFill>
-              <a:srgbClr val="8C8C8C"/>
-            </a:solidFill>
-            <a:tailEnd type="triangle" w="med" len="med"/>
-          </a:ln>
-        </p:spPr>
-        <p:style>
-          <a:lnRef idx="2">
-            <a:schemeClr val="accent1"/>
-          </a:lnRef>
-          <a:fillRef idx="0">
-            <a:schemeClr val="accent1"/>
-          </a:fillRef>
-          <a:effectRef idx="0">
-            <a:schemeClr val="accent1"/>
-          </a:effectRef>
-          <a:fontRef idx="minor">
-            <a:schemeClr val="tx1"/>
-          </a:fontRef>
-        </p:style>
-      </p:cxnSp>
-      <p:sp>
-        <p:nvSpPr>
-          <p:cNvPr id="40" name="Driver instalacao"/>
+              <a:t>centro de monitoramento de referência</a:t>
+            </a:r>
+          </a:p>
+        </p:txBody>
+      </p:sp>
+      <p:sp>
+        <p:nvSpPr>
+          <p:cNvPr id="38" name="Projeto selo 2"/>
           <p:cNvSpPr/>
           <p:nvPr/>
         </p:nvSpPr>
         <p:spPr>
           <a:xfrm>
-            <a:off x="4727448" y="4453128"/>
-            <a:ext cx="1371600" cy="777240"/>
-          </a:xfrm>
-          <a:prstGeom prst="rect">
-            <a:avLst/>
+            <a:off x="10680192" y="5001768"/>
+            <a:ext cx="1261872" cy="201168"/>
+          </a:xfrm>
+          <a:prstGeom prst="roundRect">
+            <a:avLst>
+              <a:gd name="adj" fmla="val 15000"/>
+            </a:avLst>
           </a:prstGeom>
           <a:solidFill>
-            <a:srgbClr val="009F41"/>
+            <a:srgbClr val="1A1A1A"/>
           </a:solidFill>
           <a:ln>
             <a:noFill/>
@@ -10332,43 +9887,110 @@
           <a:p>
             <a:pPr algn="ctr"/>
             <a:r>
-              <a:rPr sz="1800" b="1">
+              <a:rPr sz="850" b="1">
                 <a:solidFill>
                   <a:srgbClr val="FFFFFF"/>
                 </a:solidFill>
               </a:rPr>
-              <a:t>2027–28</a:t>
-            </a:r>
-          </a:p>
-          <a:p>
-            <a:pPr algn="ctr"/>
-            <a:r>
-              <a:rPr sz="900" b="0">
-                <a:solidFill>
-                  <a:srgbClr val="FFFFFF"/>
+              <a:t>Hikvision</a:t>
+            </a:r>
+          </a:p>
+        </p:txBody>
+      </p:sp>
+      <p:sp>
+        <p:nvSpPr>
+          <p:cNvPr id="39" name="Projeto 3"/>
+          <p:cNvSpPr txBox="1"/>
+          <p:nvPr/>
+        </p:nvSpPr>
+        <p:spPr>
+          <a:xfrm>
+            <a:off x="6473952" y="5248656"/>
+            <a:ext cx="1828800" cy="256032"/>
+          </a:xfrm>
+          <a:prstGeom prst="rect">
+            <a:avLst/>
+          </a:prstGeom>
+          <a:noFill/>
+        </p:spPr>
+        <p:txBody>
+          <a:bodyPr wrap="square" lIns="0" rIns="0" tIns="0" bIns="0" anchor="ctr">
+            <a:spAutoFit/>
+          </a:bodyPr>
+          <a:lstStyle/>
+          <a:p>
+            <a:pPr algn="l">
+              <a:spcAft>
+                <a:spcPts val="0"/>
+              </a:spcAft>
+            </a:pPr>
+            <a:r>
+              <a:rPr sz="900" b="1" i="0">
+                <a:solidFill>
+                  <a:srgbClr val="1A1A1A"/>
                 </a:solidFill>
               </a:rPr>
-              <a:t>instalação no fim da obra</a:t>
-            </a:r>
-          </a:p>
-        </p:txBody>
-      </p:sp>
-      <p:sp>
-        <p:nvSpPr>
-          <p:cNvPr id="41" name="Driver retrofit"/>
+              <a:t>Metrô do Recife</a:t>
+            </a:r>
+          </a:p>
+        </p:txBody>
+      </p:sp>
+      <p:sp>
+        <p:nvSpPr>
+          <p:cNvPr id="40" name="Projeto det 3"/>
+          <p:cNvSpPr txBox="1"/>
+          <p:nvPr/>
+        </p:nvSpPr>
+        <p:spPr>
+          <a:xfrm>
+            <a:off x="8302752" y="5248656"/>
+            <a:ext cx="2331720" cy="256032"/>
+          </a:xfrm>
+          <a:prstGeom prst="rect">
+            <a:avLst/>
+          </a:prstGeom>
+          <a:noFill/>
+        </p:spPr>
+        <p:txBody>
+          <a:bodyPr wrap="square" lIns="0" rIns="0" tIns="0" bIns="0" anchor="ctr">
+            <a:spAutoFit/>
+          </a:bodyPr>
+          <a:lstStyle/>
+          <a:p>
+            <a:pPr algn="l">
+              <a:spcAft>
+                <a:spcPts val="0"/>
+              </a:spcAft>
+            </a:pPr>
+            <a:r>
+              <a:rPr sz="850" b="0" i="0">
+                <a:solidFill>
+                  <a:srgbClr val="595959"/>
+                </a:solidFill>
+              </a:rPr>
+              <a:t>1.380 câmeras, R$61,5 mi</a:t>
+            </a:r>
+          </a:p>
+        </p:txBody>
+      </p:sp>
+      <p:sp>
+        <p:nvSpPr>
+          <p:cNvPr id="41" name="Projeto selo 3"/>
           <p:cNvSpPr/>
           <p:nvPr/>
         </p:nvSpPr>
         <p:spPr>
           <a:xfrm>
-            <a:off x="3035808" y="5367528"/>
-            <a:ext cx="3063240" cy="777240"/>
-          </a:xfrm>
-          <a:prstGeom prst="rect">
-            <a:avLst/>
+            <a:off x="10680192" y="5276088"/>
+            <a:ext cx="1261872" cy="201168"/>
+          </a:xfrm>
+          <a:prstGeom prst="roundRect">
+            <a:avLst>
+              <a:gd name="adj" fmla="val 15000"/>
+            </a:avLst>
           </a:prstGeom>
           <a:solidFill>
-            <a:srgbClr val="595959"/>
+            <a:srgbClr val="1A1A1A"/>
           </a:solidFill>
           <a:ln>
             <a:noFill/>
@@ -10395,91 +10017,330 @@
           <a:p>
             <a:pPr algn="ctr"/>
             <a:r>
-              <a:rPr sz="1200" b="1">
+              <a:rPr sz="850" b="1">
                 <a:solidFill>
                   <a:srgbClr val="FFFFFF"/>
                 </a:solidFill>
               </a:rPr>
-              <a:t>13,3 mi de unidades em condomínio</a:t>
-            </a:r>
-          </a:p>
-          <a:p>
-            <a:pPr algn="ctr"/>
-            <a:r>
-              <a:rPr sz="900" b="0">
-                <a:solidFill>
-                  <a:srgbClr val="FFFFFF"/>
-                </a:solidFill>
-              </a:rPr>
-              <a:t>retrofit: portaria remota em 14 mil condomínios, +24% em 2024</a:t>
-            </a:r>
-          </a:p>
-        </p:txBody>
-      </p:sp>
-      <p:graphicFrame>
-        <p:nvGraphicFramePr>
-          <p:cNvPr id="42" name="Grafico share Seguranca"/>
-          <p:cNvGraphicFramePr>
-            <a:graphicFrameLocks noGrp="1"/>
-          </p:cNvGraphicFramePr>
+              <a:t>Dahua</a:t>
+            </a:r>
+          </a:p>
+        </p:txBody>
+      </p:sp>
+      <p:sp>
+        <p:nvSpPr>
+          <p:cNvPr id="42" name="Projetos faixa 4"/>
+          <p:cNvSpPr/>
           <p:nvPr/>
-        </p:nvGraphicFramePr>
-        <p:xfrm>
-          <a:off x="6428232" y="4407408"/>
-          <a:ext cx="2651760" cy="1984248"/>
-        </p:xfrm>
-        <a:graphic>
-          <a:graphicData uri="http://schemas.openxmlformats.org/drawingml/2006/chart">
-            <c:chart xmlns:c="http://schemas.openxmlformats.org/drawingml/2006/chart" r:id="rId5"/>
-          </a:graphicData>
-        </a:graphic>
-      </p:graphicFrame>
-      <p:cxnSp>
-        <p:nvCxnSpPr>
-          <p:cNvPr id="43" name="Quebra de serie"/>
-          <p:cNvCxnSpPr/>
-          <p:nvPr/>
-        </p:nvCxnSpPr>
-        <p:spPr>
-          <a:xfrm>
-            <a:off x="7754112" y="4544568"/>
-            <a:ext cx="0" cy="1508760"/>
-          </a:xfrm>
-          <a:prstGeom prst="line">
-            <a:avLst/>
-          </a:prstGeom>
-          <a:ln w="12700">
-            <a:solidFill>
-              <a:srgbClr val="8C8C8C"/>
-            </a:solidFill>
-            <a:prstDash val="dash"/>
+        </p:nvSpPr>
+        <p:spPr>
+          <a:xfrm>
+            <a:off x="6428232" y="5522976"/>
+            <a:ext cx="5532120" cy="256032"/>
+          </a:xfrm>
+          <a:prstGeom prst="rect">
+            <a:avLst/>
+          </a:prstGeom>
+          <a:solidFill>
+            <a:srgbClr val="F2F2F2"/>
+          </a:solidFill>
+          <a:ln>
+            <a:noFill/>
           </a:ln>
+          <a:effectLst/>
         </p:spPr>
         <p:style>
-          <a:lnRef idx="2">
+          <a:lnRef idx="1">
             <a:schemeClr val="accent1"/>
           </a:lnRef>
-          <a:fillRef idx="0">
+          <a:fillRef idx="3">
             <a:schemeClr val="accent1"/>
           </a:fillRef>
           <a:effectRef idx="0">
             <a:schemeClr val="accent1"/>
           </a:effectRef>
           <a:fontRef idx="minor">
-            <a:schemeClr val="tx1"/>
+            <a:schemeClr val="lt1"/>
           </a:fontRef>
         </p:style>
-      </p:cxnSp>
-      <p:sp>
-        <p:nvSpPr>
-          <p:cNvPr id="44" name="Rotulo quebra"/>
+        <p:txBody>
+          <a:bodyPr rtlCol="0" anchor="ctr" lIns="36576" rIns="36576" tIns="9144" bIns="9144" wrap="square"/>
+          <a:lstStyle/>
+          <a:p>
+            <a:pPr algn="ctr"/>
+          </a:p>
+        </p:txBody>
+      </p:sp>
+      <p:sp>
+        <p:nvSpPr>
+          <p:cNvPr id="43" name="Projeto 4"/>
           <p:cNvSpPr txBox="1"/>
           <p:nvPr/>
         </p:nvSpPr>
         <p:spPr>
           <a:xfrm>
-            <a:off x="7205472" y="4389120"/>
-            <a:ext cx="1097280" cy="182880"/>
+            <a:off x="6473952" y="5522976"/>
+            <a:ext cx="1828800" cy="256032"/>
+          </a:xfrm>
+          <a:prstGeom prst="rect">
+            <a:avLst/>
+          </a:prstGeom>
+          <a:noFill/>
+        </p:spPr>
+        <p:txBody>
+          <a:bodyPr wrap="square" lIns="0" rIns="0" tIns="0" bIns="0" anchor="ctr">
+            <a:spAutoFit/>
+          </a:bodyPr>
+          <a:lstStyle/>
+          <a:p>
+            <a:pPr algn="l">
+              <a:spcAft>
+                <a:spcPts val="0"/>
+              </a:spcAft>
+            </a:pPr>
+            <a:r>
+              <a:rPr sz="900" b="1" i="0">
+                <a:solidFill>
+                  <a:srgbClr val="1A1A1A"/>
+                </a:solidFill>
+              </a:rPr>
+              <a:t>Campinas (cidade segura)</a:t>
+            </a:r>
+          </a:p>
+        </p:txBody>
+      </p:sp>
+      <p:sp>
+        <p:nvSpPr>
+          <p:cNvPr id="44" name="Projeto det 4"/>
+          <p:cNvSpPr txBox="1"/>
+          <p:nvPr/>
+        </p:nvSpPr>
+        <p:spPr>
+          <a:xfrm>
+            <a:off x="8302752" y="5522976"/>
+            <a:ext cx="2331720" cy="256032"/>
+          </a:xfrm>
+          <a:prstGeom prst="rect">
+            <a:avLst/>
+          </a:prstGeom>
+          <a:noFill/>
+        </p:spPr>
+        <p:txBody>
+          <a:bodyPr wrap="square" lIns="0" rIns="0" tIns="0" bIns="0" anchor="ctr">
+            <a:spAutoFit/>
+          </a:bodyPr>
+          <a:lstStyle/>
+          <a:p>
+            <a:pPr algn="l">
+              <a:spcAft>
+                <a:spcPts val="0"/>
+              </a:spcAft>
+            </a:pPr>
+            <a:r>
+              <a:rPr sz="850" b="0" i="0">
+                <a:solidFill>
+                  <a:srgbClr val="595959"/>
+                </a:solidFill>
+              </a:rPr>
+              <a:t>parceria com o CPqD</a:t>
+            </a:r>
+          </a:p>
+        </p:txBody>
+      </p:sp>
+      <p:sp>
+        <p:nvSpPr>
+          <p:cNvPr id="45" name="Projeto selo 4"/>
+          <p:cNvSpPr/>
+          <p:nvPr/>
+        </p:nvSpPr>
+        <p:spPr>
+          <a:xfrm>
+            <a:off x="10680192" y="5550408"/>
+            <a:ext cx="1261872" cy="201168"/>
+          </a:xfrm>
+          <a:prstGeom prst="roundRect">
+            <a:avLst>
+              <a:gd name="adj" fmla="val 15000"/>
+            </a:avLst>
+          </a:prstGeom>
+          <a:solidFill>
+            <a:srgbClr val="BFBFBF"/>
+          </a:solidFill>
+          <a:ln>
+            <a:noFill/>
+          </a:ln>
+          <a:effectLst/>
+        </p:spPr>
+        <p:style>
+          <a:lnRef idx="1">
+            <a:schemeClr val="accent1"/>
+          </a:lnRef>
+          <a:fillRef idx="3">
+            <a:schemeClr val="accent1"/>
+          </a:fillRef>
+          <a:effectRef idx="0">
+            <a:schemeClr val="accent1"/>
+          </a:effectRef>
+          <a:fontRef idx="minor">
+            <a:schemeClr val="lt1"/>
+          </a:fontRef>
+        </p:style>
+        <p:txBody>
+          <a:bodyPr rtlCol="0" anchor="ctr" lIns="36576" rIns="36576" tIns="9144" bIns="9144" wrap="square"/>
+          <a:lstStyle/>
+          <a:p>
+            <a:pPr algn="ctr"/>
+            <a:r>
+              <a:rPr sz="850" b="1">
+                <a:solidFill>
+                  <a:srgbClr val="1A1A1A"/>
+                </a:solidFill>
+              </a:rPr>
+              <a:t>Huawei</a:t>
+            </a:r>
+          </a:p>
+        </p:txBody>
+      </p:sp>
+      <p:sp>
+        <p:nvSpPr>
+          <p:cNvPr id="46" name="Projeto 5"/>
+          <p:cNvSpPr txBox="1"/>
+          <p:nvPr/>
+        </p:nvSpPr>
+        <p:spPr>
+          <a:xfrm>
+            <a:off x="6473952" y="5797296"/>
+            <a:ext cx="1828800" cy="256032"/>
+          </a:xfrm>
+          <a:prstGeom prst="rect">
+            <a:avLst/>
+          </a:prstGeom>
+          <a:noFill/>
+        </p:spPr>
+        <p:txBody>
+          <a:bodyPr wrap="square" lIns="0" rIns="0" tIns="0" bIns="0" anchor="ctr">
+            <a:spAutoFit/>
+          </a:bodyPr>
+          <a:lstStyle/>
+          <a:p>
+            <a:pPr algn="l">
+              <a:spcAft>
+                <a:spcPts val="0"/>
+              </a:spcAft>
+            </a:pPr>
+            <a:r>
+              <a:rPr sz="900" b="1" i="0">
+                <a:solidFill>
+                  <a:srgbClr val="009F41"/>
+                </a:solidFill>
+              </a:rPr>
+              <a:t>Intelbras</a:t>
+            </a:r>
+          </a:p>
+        </p:txBody>
+      </p:sp>
+      <p:sp>
+        <p:nvSpPr>
+          <p:cNvPr id="47" name="Projeto det 5"/>
+          <p:cNvSpPr txBox="1"/>
+          <p:nvPr/>
+        </p:nvSpPr>
+        <p:spPr>
+          <a:xfrm>
+            <a:off x="8302752" y="5797296"/>
+            <a:ext cx="2331720" cy="256032"/>
+          </a:xfrm>
+          <a:prstGeom prst="rect">
+            <a:avLst/>
+          </a:prstGeom>
+          <a:noFill/>
+        </p:spPr>
+        <p:txBody>
+          <a:bodyPr wrap="square" lIns="0" rIns="0" tIns="0" bIns="0" anchor="ctr">
+            <a:spAutoFit/>
+          </a:bodyPr>
+          <a:lstStyle/>
+          <a:p>
+            <a:pPr algn="l">
+              <a:spcAft>
+                <a:spcPts val="0"/>
+              </a:spcAft>
+            </a:pPr>
+            <a:r>
+              <a:rPr sz="850" b="0" i="0">
+                <a:solidFill>
+                  <a:srgbClr val="595959"/>
+                </a:solidFill>
+              </a:rPr>
+              <a:t>via integradores (≤16% das vendas); "avanço gradual"</a:t>
+            </a:r>
+          </a:p>
+        </p:txBody>
+      </p:sp>
+      <p:sp>
+        <p:nvSpPr>
+          <p:cNvPr id="48" name="Projeto selo 5"/>
+          <p:cNvSpPr/>
+          <p:nvPr/>
+        </p:nvSpPr>
+        <p:spPr>
+          <a:xfrm>
+            <a:off x="10680192" y="5824728"/>
+            <a:ext cx="1261872" cy="201168"/>
+          </a:xfrm>
+          <a:prstGeom prst="roundRect">
+            <a:avLst>
+              <a:gd name="adj" fmla="val 15000"/>
+            </a:avLst>
+          </a:prstGeom>
+          <a:solidFill>
+            <a:srgbClr val="009F41"/>
+          </a:solidFill>
+          <a:ln>
+            <a:noFill/>
+          </a:ln>
+          <a:effectLst/>
+        </p:spPr>
+        <p:style>
+          <a:lnRef idx="1">
+            <a:schemeClr val="accent1"/>
+          </a:lnRef>
+          <a:fillRef idx="3">
+            <a:schemeClr val="accent1"/>
+          </a:fillRef>
+          <a:effectRef idx="0">
+            <a:schemeClr val="accent1"/>
+          </a:effectRef>
+          <a:fontRef idx="minor">
+            <a:schemeClr val="lt1"/>
+          </a:fontRef>
+        </p:style>
+        <p:txBody>
+          <a:bodyPr rtlCol="0" anchor="ctr" lIns="36576" rIns="36576" tIns="9144" bIns="9144" wrap="square"/>
+          <a:lstStyle/>
+          <a:p>
+            <a:pPr algn="ctr"/>
+            <a:r>
+              <a:rPr sz="850" b="1">
+                <a:solidFill>
+                  <a:srgbClr val="FFFFFF"/>
+                </a:solidFill>
+              </a:rPr>
+              <a:t>cases pontuais</a:t>
+            </a:r>
+          </a:p>
+        </p:txBody>
+      </p:sp>
+      <p:sp>
+        <p:nvSpPr>
+          <p:cNvPr id="49" name="Nota Dahua projetos"/>
+          <p:cNvSpPr txBox="1"/>
+          <p:nvPr/>
+        </p:nvSpPr>
+        <p:spPr>
+          <a:xfrm>
+            <a:off x="6428232" y="6099048"/>
+            <a:ext cx="5532120" cy="292608"/>
           </a:xfrm>
           <a:prstGeom prst="rect">
             <a:avLst/>
@@ -10492,74 +10353,18 @@
           </a:bodyPr>
           <a:lstStyle/>
           <a:p>
-            <a:pPr algn="ctr">
+            <a:pPr algn="l">
               <a:spcAft>
                 <a:spcPts val="0"/>
               </a:spcAft>
             </a:pPr>
             <a:r>
-              <a:rPr sz="800" b="0" i="1">
-                <a:solidFill>
-                  <a:srgbClr val="6B6B6B"/>
+              <a:rPr sz="850" b="1" i="1">
+                <a:solidFill>
+                  <a:srgbClr val="1A1A1A"/>
                 </a:solidFill>
               </a:rPr>
-              <a:t>quebra de série</a:t>
-            </a:r>
-          </a:p>
-        </p:txBody>
-      </p:sp>
-      <p:graphicFrame>
-        <p:nvGraphicFramePr>
-          <p:cNvPr id="45" name="Grafico margem Seguranca"/>
-          <p:cNvGraphicFramePr>
-            <a:graphicFrameLocks noGrp="1"/>
-          </p:cNvGraphicFramePr>
-          <p:nvPr/>
-        </p:nvGraphicFramePr>
-        <p:xfrm>
-          <a:off x="9262872" y="4407408"/>
-          <a:ext cx="2697480" cy="1984248"/>
-        </p:xfrm>
-        <a:graphic>
-          <a:graphicData uri="http://schemas.openxmlformats.org/drawingml/2006/chart">
-            <c:chart xmlns:c="http://schemas.openxmlformats.org/drawingml/2006/chart" r:id="rId6"/>
-          </a:graphicData>
-        </a:graphic>
-      </p:graphicFrame>
-      <p:sp>
-        <p:nvSpPr>
-          <p:cNvPr id="46" name="Rotulo margem"/>
-          <p:cNvSpPr txBox="1"/>
-          <p:nvPr/>
-        </p:nvSpPr>
-        <p:spPr>
-          <a:xfrm>
-            <a:off x="9262872" y="4389120"/>
-            <a:ext cx="2697480" cy="182880"/>
-          </a:xfrm>
-          <a:prstGeom prst="rect">
-            <a:avLst/>
-          </a:prstGeom>
-          <a:noFill/>
-        </p:spPr>
-        <p:txBody>
-          <a:bodyPr wrap="square" lIns="0" rIns="0" tIns="0" bIns="0" anchor="t">
-            <a:spAutoFit/>
-          </a:bodyPr>
-          <a:lstStyle/>
-          <a:p>
-            <a:pPr algn="ctr">
-              <a:spcAft>
-                <a:spcPts val="0"/>
-              </a:spcAft>
-            </a:pPr>
-            <a:r>
-              <a:rPr sz="850" b="0" i="1">
-                <a:solidFill>
-                  <a:srgbClr val="595959"/>
-                </a:solidFill>
-              </a:rPr>
-              <a:t>margem bruta (%)</a:t>
+              <a:t>O acordo de acionistas deixa a Dahua livre para competir em projetos (cl. 12.1): nas cidades, a fornecedora é a rival.</a:t>
             </a:r>
           </a:p>
         </p:txBody>

</xml_diff>